<commit_message>
final report and PPT
</commit_message>
<xml_diff>
--- a/DOCUMENTS/Presentation_Assignment2.pptx
+++ b/DOCUMENTS/Presentation_Assignment2.pptx
@@ -5,7 +5,7 @@
     <p:sldMasterId id="2147483648" r:id="rId1"/>
   </p:sldMasterIdLst>
   <p:notesMasterIdLst>
-    <p:notesMasterId r:id="rId26"/>
+    <p:notesMasterId r:id="rId28"/>
   </p:notesMasterIdLst>
   <p:sldIdLst>
     <p:sldId id="260" r:id="rId2"/>
@@ -26,12 +26,14 @@
     <p:sldId id="276" r:id="rId17"/>
     <p:sldId id="277" r:id="rId18"/>
     <p:sldId id="279" r:id="rId19"/>
-    <p:sldId id="284" r:id="rId20"/>
-    <p:sldId id="285" r:id="rId21"/>
-    <p:sldId id="286" r:id="rId22"/>
-    <p:sldId id="278" r:id="rId23"/>
-    <p:sldId id="287" r:id="rId24"/>
-    <p:sldId id="268" r:id="rId25"/>
+    <p:sldId id="289" r:id="rId20"/>
+    <p:sldId id="284" r:id="rId21"/>
+    <p:sldId id="285" r:id="rId22"/>
+    <p:sldId id="286" r:id="rId23"/>
+    <p:sldId id="288" r:id="rId24"/>
+    <p:sldId id="278" r:id="rId25"/>
+    <p:sldId id="287" r:id="rId26"/>
+    <p:sldId id="268" r:id="rId27"/>
   </p:sldIdLst>
   <p:sldSz cx="12192000" cy="6858000"/>
   <p:notesSz cx="6858000" cy="9144000"/>
@@ -141,7 +143,7 @@
 <file path=ppt/revisionInfo.xml><?xml version="1.0" encoding="utf-8"?>
 <p1510:revInfo xmlns:a="http://schemas.openxmlformats.org/drawingml/2006/main" xmlns:r="http://schemas.openxmlformats.org/officeDocument/2006/relationships" xmlns:p1510="http://schemas.microsoft.com/office/powerpoint/2015/10/main">
   <p1510:revLst>
-    <p1510:client id="{37E763BE-9A41-40D2-BA6F-2D00CB730218}" v="67" dt="2026-09-13T12:11:28.247"/>
+    <p1510:client id="{37E763BE-9A41-40D2-BA6F-2D00CB730218}" v="69" dt="2026-09-13T13:25:31.425"/>
   </p1510:revLst>
 </p1510:revInfo>
 </file>
@@ -151,7 +153,7 @@
   <pc:docChgLst>
     <pc:chgData name="sonam pelden" userId="2f903a43345a64cb" providerId="LiveId" clId="{436BA98B-5571-47CE-82CC-956A605DEA26}"/>
     <pc:docChg chg="undo custSel addSld delSld modSld sldOrd">
-      <pc:chgData name="sonam pelden" userId="2f903a43345a64cb" providerId="LiveId" clId="{436BA98B-5571-47CE-82CC-956A605DEA26}" dt="2026-09-13T12:11:34.166" v="630" actId="20577"/>
+      <pc:chgData name="sonam pelden" userId="2f903a43345a64cb" providerId="LiveId" clId="{436BA98B-5571-47CE-82CC-956A605DEA26}" dt="2026-09-13T13:27:52.254" v="647" actId="20577"/>
       <pc:docMkLst>
         <pc:docMk/>
       </pc:docMkLst>
@@ -2693,6 +2695,204 @@
             <pc:docMk/>
             <pc:sldMk cId="3577401227" sldId="287"/>
             <ac:spMk id="40" creationId="{503BBC7C-A780-043C-E453-1203691C2246}"/>
+          </ac:spMkLst>
+        </pc:spChg>
+      </pc:sldChg>
+      <pc:sldChg chg="modSp add mod">
+        <pc:chgData name="sonam pelden" userId="2f903a43345a64cb" providerId="LiveId" clId="{436BA98B-5571-47CE-82CC-956A605DEA26}" dt="2026-09-13T13:27:52.254" v="647" actId="20577"/>
+        <pc:sldMkLst>
+          <pc:docMk/>
+          <pc:sldMk cId="0" sldId="288"/>
+        </pc:sldMkLst>
+        <pc:spChg chg="mod">
+          <ac:chgData name="sonam pelden" userId="2f903a43345a64cb" providerId="LiveId" clId="{436BA98B-5571-47CE-82CC-956A605DEA26}" dt="2026-09-13T13:27:39.608" v="645" actId="255"/>
+          <ac:spMkLst>
+            <pc:docMk/>
+            <pc:sldMk cId="0" sldId="288"/>
+            <ac:spMk id="3" creationId="{00000000-0000-0000-0000-000000000000}"/>
+          </ac:spMkLst>
+        </pc:spChg>
+        <pc:spChg chg="mod">
+          <ac:chgData name="sonam pelden" userId="2f903a43345a64cb" providerId="LiveId" clId="{436BA98B-5571-47CE-82CC-956A605DEA26}" dt="2026-09-13T13:27:33.466" v="644" actId="255"/>
+          <ac:spMkLst>
+            <pc:docMk/>
+            <pc:sldMk cId="0" sldId="288"/>
+            <ac:spMk id="7" creationId="{00000000-0000-0000-0000-000000000000}"/>
+          </ac:spMkLst>
+        </pc:spChg>
+        <pc:spChg chg="mod">
+          <ac:chgData name="sonam pelden" userId="2f903a43345a64cb" providerId="LiveId" clId="{436BA98B-5571-47CE-82CC-956A605DEA26}" dt="2026-09-13T13:27:33.466" v="644" actId="255"/>
+          <ac:spMkLst>
+            <pc:docMk/>
+            <pc:sldMk cId="0" sldId="288"/>
+            <ac:spMk id="9" creationId="{00000000-0000-0000-0000-000000000000}"/>
+          </ac:spMkLst>
+        </pc:spChg>
+        <pc:spChg chg="mod">
+          <ac:chgData name="sonam pelden" userId="2f903a43345a64cb" providerId="LiveId" clId="{436BA98B-5571-47CE-82CC-956A605DEA26}" dt="2026-09-13T13:27:33.466" v="644" actId="255"/>
+          <ac:spMkLst>
+            <pc:docMk/>
+            <pc:sldMk cId="0" sldId="288"/>
+            <ac:spMk id="14" creationId="{00000000-0000-0000-0000-000000000000}"/>
+          </ac:spMkLst>
+        </pc:spChg>
+        <pc:spChg chg="mod">
+          <ac:chgData name="sonam pelden" userId="2f903a43345a64cb" providerId="LiveId" clId="{436BA98B-5571-47CE-82CC-956A605DEA26}" dt="2026-09-13T13:27:33.466" v="644" actId="255"/>
+          <ac:spMkLst>
+            <pc:docMk/>
+            <pc:sldMk cId="0" sldId="288"/>
+            <ac:spMk id="16" creationId="{00000000-0000-0000-0000-000000000000}"/>
+          </ac:spMkLst>
+        </pc:spChg>
+        <pc:spChg chg="mod">
+          <ac:chgData name="sonam pelden" userId="2f903a43345a64cb" providerId="LiveId" clId="{436BA98B-5571-47CE-82CC-956A605DEA26}" dt="2026-09-13T13:27:33.466" v="644" actId="255"/>
+          <ac:spMkLst>
+            <pc:docMk/>
+            <pc:sldMk cId="0" sldId="288"/>
+            <ac:spMk id="18" creationId="{00000000-0000-0000-0000-000000000000}"/>
+          </ac:spMkLst>
+        </pc:spChg>
+        <pc:spChg chg="mod">
+          <ac:chgData name="sonam pelden" userId="2f903a43345a64cb" providerId="LiveId" clId="{436BA98B-5571-47CE-82CC-956A605DEA26}" dt="2026-09-13T13:27:33.466" v="644" actId="255"/>
+          <ac:spMkLst>
+            <pc:docMk/>
+            <pc:sldMk cId="0" sldId="288"/>
+            <ac:spMk id="22" creationId="{00000000-0000-0000-0000-000000000000}"/>
+          </ac:spMkLst>
+        </pc:spChg>
+        <pc:spChg chg="mod">
+          <ac:chgData name="sonam pelden" userId="2f903a43345a64cb" providerId="LiveId" clId="{436BA98B-5571-47CE-82CC-956A605DEA26}" dt="2026-09-13T13:27:33.466" v="644" actId="255"/>
+          <ac:spMkLst>
+            <pc:docMk/>
+            <pc:sldMk cId="0" sldId="288"/>
+            <ac:spMk id="23" creationId="{00000000-0000-0000-0000-000000000000}"/>
+          </ac:spMkLst>
+        </pc:spChg>
+        <pc:spChg chg="mod">
+          <ac:chgData name="sonam pelden" userId="2f903a43345a64cb" providerId="LiveId" clId="{436BA98B-5571-47CE-82CC-956A605DEA26}" dt="2026-09-13T13:27:33.466" v="644" actId="255"/>
+          <ac:spMkLst>
+            <pc:docMk/>
+            <pc:sldMk cId="0" sldId="288"/>
+            <ac:spMk id="24" creationId="{00000000-0000-0000-0000-000000000000}"/>
+          </ac:spMkLst>
+        </pc:spChg>
+        <pc:spChg chg="mod">
+          <ac:chgData name="sonam pelden" userId="2f903a43345a64cb" providerId="LiveId" clId="{436BA98B-5571-47CE-82CC-956A605DEA26}" dt="2026-09-13T13:27:52.254" v="647" actId="20577"/>
+          <ac:spMkLst>
+            <pc:docMk/>
+            <pc:sldMk cId="0" sldId="288"/>
+            <ac:spMk id="26" creationId="{00000000-0000-0000-0000-000000000000}"/>
+          </ac:spMkLst>
+        </pc:spChg>
+        <pc:spChg chg="mod">
+          <ac:chgData name="sonam pelden" userId="2f903a43345a64cb" providerId="LiveId" clId="{436BA98B-5571-47CE-82CC-956A605DEA26}" dt="2026-09-13T13:27:33.466" v="644" actId="255"/>
+          <ac:spMkLst>
+            <pc:docMk/>
+            <pc:sldMk cId="0" sldId="288"/>
+            <ac:spMk id="28" creationId="{00000000-0000-0000-0000-000000000000}"/>
+          </ac:spMkLst>
+        </pc:spChg>
+      </pc:sldChg>
+      <pc:sldChg chg="addSp delSp modSp add mod ord">
+        <pc:chgData name="sonam pelden" userId="2f903a43345a64cb" providerId="LiveId" clId="{436BA98B-5571-47CE-82CC-956A605DEA26}" dt="2026-09-13T13:27:13.205" v="643" actId="255"/>
+        <pc:sldMkLst>
+          <pc:docMk/>
+          <pc:sldMk cId="0" sldId="289"/>
+        </pc:sldMkLst>
+        <pc:spChg chg="add del mod">
+          <ac:chgData name="sonam pelden" userId="2f903a43345a64cb" providerId="LiveId" clId="{436BA98B-5571-47CE-82CC-956A605DEA26}" dt="2026-09-13T13:26:32.752" v="639" actId="20577"/>
+          <ac:spMkLst>
+            <pc:docMk/>
+            <pc:sldMk cId="0" sldId="289"/>
+            <ac:spMk id="2" creationId="{00000000-0000-0000-0000-000000000000}"/>
+          </ac:spMkLst>
+        </pc:spChg>
+        <pc:spChg chg="mod">
+          <ac:chgData name="sonam pelden" userId="2f903a43345a64cb" providerId="LiveId" clId="{436BA98B-5571-47CE-82CC-956A605DEA26}" dt="2026-09-13T13:27:13.205" v="643" actId="255"/>
+          <ac:spMkLst>
+            <pc:docMk/>
+            <pc:sldMk cId="0" sldId="289"/>
+            <ac:spMk id="3" creationId="{00000000-0000-0000-0000-000000000000}"/>
+          </ac:spMkLst>
+        </pc:spChg>
+        <pc:spChg chg="mod">
+          <ac:chgData name="sonam pelden" userId="2f903a43345a64cb" providerId="LiveId" clId="{436BA98B-5571-47CE-82CC-956A605DEA26}" dt="2026-09-13T13:26:49.743" v="640" actId="255"/>
+          <ac:spMkLst>
+            <pc:docMk/>
+            <pc:sldMk cId="0" sldId="289"/>
+            <ac:spMk id="5" creationId="{00000000-0000-0000-0000-000000000000}"/>
+          </ac:spMkLst>
+        </pc:spChg>
+        <pc:spChg chg="mod">
+          <ac:chgData name="sonam pelden" userId="2f903a43345a64cb" providerId="LiveId" clId="{436BA98B-5571-47CE-82CC-956A605DEA26}" dt="2026-09-13T13:26:49.743" v="640" actId="255"/>
+          <ac:spMkLst>
+            <pc:docMk/>
+            <pc:sldMk cId="0" sldId="289"/>
+            <ac:spMk id="6" creationId="{00000000-0000-0000-0000-000000000000}"/>
+          </ac:spMkLst>
+        </pc:spChg>
+        <pc:spChg chg="mod">
+          <ac:chgData name="sonam pelden" userId="2f903a43345a64cb" providerId="LiveId" clId="{436BA98B-5571-47CE-82CC-956A605DEA26}" dt="2026-09-13T13:26:58.110" v="641" actId="255"/>
+          <ac:spMkLst>
+            <pc:docMk/>
+            <pc:sldMk cId="0" sldId="289"/>
+            <ac:spMk id="8" creationId="{00000000-0000-0000-0000-000000000000}"/>
+          </ac:spMkLst>
+        </pc:spChg>
+        <pc:spChg chg="mod">
+          <ac:chgData name="sonam pelden" userId="2f903a43345a64cb" providerId="LiveId" clId="{436BA98B-5571-47CE-82CC-956A605DEA26}" dt="2026-09-13T13:26:49.743" v="640" actId="255"/>
+          <ac:spMkLst>
+            <pc:docMk/>
+            <pc:sldMk cId="0" sldId="289"/>
+            <ac:spMk id="9" creationId="{00000000-0000-0000-0000-000000000000}"/>
+          </ac:spMkLst>
+        </pc:spChg>
+        <pc:spChg chg="mod">
+          <ac:chgData name="sonam pelden" userId="2f903a43345a64cb" providerId="LiveId" clId="{436BA98B-5571-47CE-82CC-956A605DEA26}" dt="2026-09-13T13:27:03.637" v="642" actId="255"/>
+          <ac:spMkLst>
+            <pc:docMk/>
+            <pc:sldMk cId="0" sldId="289"/>
+            <ac:spMk id="10" creationId="{00000000-0000-0000-0000-000000000000}"/>
+          </ac:spMkLst>
+        </pc:spChg>
+        <pc:spChg chg="mod">
+          <ac:chgData name="sonam pelden" userId="2f903a43345a64cb" providerId="LiveId" clId="{436BA98B-5571-47CE-82CC-956A605DEA26}" dt="2026-09-13T13:26:49.743" v="640" actId="255"/>
+          <ac:spMkLst>
+            <pc:docMk/>
+            <pc:sldMk cId="0" sldId="289"/>
+            <ac:spMk id="11" creationId="{00000000-0000-0000-0000-000000000000}"/>
+          </ac:spMkLst>
+        </pc:spChg>
+        <pc:spChg chg="mod">
+          <ac:chgData name="sonam pelden" userId="2f903a43345a64cb" providerId="LiveId" clId="{436BA98B-5571-47CE-82CC-956A605DEA26}" dt="2026-09-13T13:26:49.743" v="640" actId="255"/>
+          <ac:spMkLst>
+            <pc:docMk/>
+            <pc:sldMk cId="0" sldId="289"/>
+            <ac:spMk id="12" creationId="{00000000-0000-0000-0000-000000000000}"/>
+          </ac:spMkLst>
+        </pc:spChg>
+        <pc:spChg chg="mod">
+          <ac:chgData name="sonam pelden" userId="2f903a43345a64cb" providerId="LiveId" clId="{436BA98B-5571-47CE-82CC-956A605DEA26}" dt="2026-09-13T13:26:49.743" v="640" actId="255"/>
+          <ac:spMkLst>
+            <pc:docMk/>
+            <pc:sldMk cId="0" sldId="289"/>
+            <ac:spMk id="13" creationId="{00000000-0000-0000-0000-000000000000}"/>
+          </ac:spMkLst>
+        </pc:spChg>
+        <pc:spChg chg="mod">
+          <ac:chgData name="sonam pelden" userId="2f903a43345a64cb" providerId="LiveId" clId="{436BA98B-5571-47CE-82CC-956A605DEA26}" dt="2026-09-13T13:26:49.743" v="640" actId="255"/>
+          <ac:spMkLst>
+            <pc:docMk/>
+            <pc:sldMk cId="0" sldId="289"/>
+            <ac:spMk id="15" creationId="{00000000-0000-0000-0000-000000000000}"/>
+          </ac:spMkLst>
+        </pc:spChg>
+        <pc:spChg chg="mod">
+          <ac:chgData name="sonam pelden" userId="2f903a43345a64cb" providerId="LiveId" clId="{436BA98B-5571-47CE-82CC-956A605DEA26}" dt="2026-09-13T13:26:49.743" v="640" actId="255"/>
+          <ac:spMkLst>
+            <pc:docMk/>
+            <pc:sldMk cId="0" sldId="289"/>
+            <ac:spMk id="16" creationId="{00000000-0000-0000-0000-000000000000}"/>
           </ac:spMkLst>
         </pc:spChg>
       </pc:sldChg>
@@ -7333,6 +7533,90 @@
   <p:cSld>
     <p:spTree>
       <p:nvGrpSpPr>
+        <p:cNvPr id="1" name=""/>
+        <p:cNvGrpSpPr/>
+        <p:nvPr/>
+      </p:nvGrpSpPr>
+      <p:grpSpPr>
+        <a:xfrm>
+          <a:off x="0" y="0"/>
+          <a:ext cx="0" cy="0"/>
+          <a:chOff x="0" y="0"/>
+          <a:chExt cx="0" cy="0"/>
+        </a:xfrm>
+      </p:grpSpPr>
+      <p:sp>
+        <p:nvSpPr>
+          <p:cNvPr id="2" name="Slide Image Placeholder 1"/>
+          <p:cNvSpPr>
+            <a:spLocks noGrp="1" noRot="1" noChangeAspect="1"/>
+          </p:cNvSpPr>
+          <p:nvPr>
+            <p:ph type="sldImg"/>
+          </p:nvPr>
+        </p:nvSpPr>
+        <p:spPr/>
+      </p:sp>
+      <p:sp>
+        <p:nvSpPr>
+          <p:cNvPr id="3" name="Notes Placeholder 2"/>
+          <p:cNvSpPr>
+            <a:spLocks noGrp="1"/>
+          </p:cNvSpPr>
+          <p:nvPr>
+            <p:ph type="body" idx="1"/>
+          </p:nvPr>
+        </p:nvSpPr>
+        <p:spPr/>
+        <p:txBody>
+          <a:bodyPr/>
+          <a:lstStyle/>
+          <a:p>
+            <a:endParaRPr lang="en-US" dirty="0"/>
+          </a:p>
+        </p:txBody>
+      </p:sp>
+      <p:sp>
+        <p:nvSpPr>
+          <p:cNvPr id="4" name="Slide Number Placeholder 3"/>
+          <p:cNvSpPr>
+            <a:spLocks noGrp="1"/>
+          </p:cNvSpPr>
+          <p:nvPr>
+            <p:ph type="sldNum" sz="quarter" idx="10"/>
+          </p:nvPr>
+        </p:nvSpPr>
+        <p:spPr/>
+        <p:txBody>
+          <a:bodyPr/>
+          <a:lstStyle/>
+          <a:p>
+            <a:fld id="{F7021451-1387-4CA6-816F-3879F97B5CBC}" type="slidenum">
+              <a:rPr lang="en-US"/>
+              <a:t>19</a:t>
+            </a:fld>
+            <a:endParaRPr lang="en-US"/>
+          </a:p>
+        </p:txBody>
+      </p:sp>
+    </p:spTree>
+    <p:extLst>
+      <p:ext uri="{BB962C8B-B14F-4D97-AF65-F5344CB8AC3E}">
+        <p14:creationId xmlns:p14="http://schemas.microsoft.com/office/powerpoint/2010/main" val="1024086991"/>
+      </p:ext>
+    </p:extLst>
+  </p:cSld>
+  <p:clrMapOvr>
+    <a:masterClrMapping/>
+  </p:clrMapOvr>
+</p:notes>
+</file>
+
+<file path=ppt/notesSlides/notesSlide13.xml><?xml version="1.0" encoding="utf-8"?>
+<p:notes xmlns:a="http://schemas.openxmlformats.org/drawingml/2006/main" xmlns:r="http://schemas.openxmlformats.org/officeDocument/2006/relationships" xmlns:p="http://schemas.openxmlformats.org/presentationml/2006/main">
+  <p:cSld>
+    <p:spTree>
+      <p:nvGrpSpPr>
         <p:cNvPr id="1" name="">
           <a:extLst>
             <a:ext uri="{FF2B5EF4-FFF2-40B4-BE49-F238E27FC236}">
@@ -7424,7 +7708,7 @@
           <a:p>
             <a:fld id="{F7021451-1387-4CA6-816F-3879F97B5CBC}" type="slidenum">
               <a:rPr lang="en-US"/>
-              <a:t>20</a:t>
+              <a:t>21</a:t>
             </a:fld>
             <a:endParaRPr lang="en-US"/>
           </a:p>
@@ -7443,7 +7727,7 @@
 </p:notes>
 </file>
 
-<file path=ppt/notesSlides/notesSlide13.xml><?xml version="1.0" encoding="utf-8"?>
+<file path=ppt/notesSlides/notesSlide14.xml><?xml version="1.0" encoding="utf-8"?>
 <p:notes xmlns:a="http://schemas.openxmlformats.org/drawingml/2006/main" xmlns:r="http://schemas.openxmlformats.org/officeDocument/2006/relationships" xmlns:p="http://schemas.openxmlformats.org/presentationml/2006/main">
   <p:cSld>
     <p:spTree>
@@ -7508,7 +7792,7 @@
           <a:p>
             <a:fld id="{F7021451-1387-4CA6-816F-3879F97B5CBC}" type="slidenum">
               <a:rPr lang="en-US"/>
-              <a:t>22</a:t>
+              <a:t>23</a:t>
             </a:fld>
             <a:endParaRPr lang="en-US"/>
           </a:p>
@@ -7517,122 +7801,7 @@
     </p:spTree>
     <p:extLst>
       <p:ext uri="{BB962C8B-B14F-4D97-AF65-F5344CB8AC3E}">
-        <p14:creationId xmlns:p14="http://schemas.microsoft.com/office/powerpoint/2010/main" val="4054984044"/>
-      </p:ext>
-    </p:extLst>
-  </p:cSld>
-  <p:clrMapOvr>
-    <a:masterClrMapping/>
-  </p:clrMapOvr>
-</p:notes>
-</file>
-
-<file path=ppt/notesSlides/notesSlide14.xml><?xml version="1.0" encoding="utf-8"?>
-<p:notes xmlns:a="http://schemas.openxmlformats.org/drawingml/2006/main" xmlns:r="http://schemas.openxmlformats.org/officeDocument/2006/relationships" xmlns:p="http://schemas.openxmlformats.org/presentationml/2006/main">
-  <p:cSld>
-    <p:spTree>
-      <p:nvGrpSpPr>
-        <p:cNvPr id="1" name="">
-          <a:extLst>
-            <a:ext uri="{FF2B5EF4-FFF2-40B4-BE49-F238E27FC236}">
-              <a16:creationId xmlns:a16="http://schemas.microsoft.com/office/drawing/2014/main" id="{8AFC76FB-330B-AE8A-F590-349BD895D746}"/>
-            </a:ext>
-          </a:extLst>
-        </p:cNvPr>
-        <p:cNvGrpSpPr/>
-        <p:nvPr/>
-      </p:nvGrpSpPr>
-      <p:grpSpPr>
-        <a:xfrm>
-          <a:off x="0" y="0"/>
-          <a:ext cx="0" cy="0"/>
-          <a:chOff x="0" y="0"/>
-          <a:chExt cx="0" cy="0"/>
-        </a:xfrm>
-      </p:grpSpPr>
-      <p:sp>
-        <p:nvSpPr>
-          <p:cNvPr id="2" name="Slide Image Placeholder 1">
-            <a:extLst>
-              <a:ext uri="{FF2B5EF4-FFF2-40B4-BE49-F238E27FC236}">
-                <a16:creationId xmlns:a16="http://schemas.microsoft.com/office/drawing/2014/main" id="{D4F6FBFC-D2BC-59F9-2133-1EF554C92D81}"/>
-              </a:ext>
-            </a:extLst>
-          </p:cNvPr>
-          <p:cNvSpPr>
-            <a:spLocks noGrp="1" noRot="1" noChangeAspect="1"/>
-          </p:cNvSpPr>
-          <p:nvPr>
-            <p:ph type="sldImg"/>
-          </p:nvPr>
-        </p:nvSpPr>
-        <p:spPr/>
-        <p:txBody>
-          <a:bodyPr/>
-          <a:lstStyle/>
-          <a:p>
-            <a:endParaRPr lang="en-US"/>
-          </a:p>
-        </p:txBody>
-      </p:sp>
-      <p:sp>
-        <p:nvSpPr>
-          <p:cNvPr id="3" name="Notes Placeholder 2">
-            <a:extLst>
-              <a:ext uri="{FF2B5EF4-FFF2-40B4-BE49-F238E27FC236}">
-                <a16:creationId xmlns:a16="http://schemas.microsoft.com/office/drawing/2014/main" id="{97A65F92-03C7-0B2D-E9B5-578E1E5D861A}"/>
-              </a:ext>
-            </a:extLst>
-          </p:cNvPr>
-          <p:cNvSpPr>
-            <a:spLocks noGrp="1"/>
-          </p:cNvSpPr>
-          <p:nvPr>
-            <p:ph type="body" idx="1"/>
-          </p:nvPr>
-        </p:nvSpPr>
-        <p:spPr/>
-        <p:txBody>
-          <a:bodyPr/>
-          <a:lstStyle/>
-          <a:p>
-            <a:endParaRPr lang="en-US" dirty="0"/>
-          </a:p>
-        </p:txBody>
-      </p:sp>
-      <p:sp>
-        <p:nvSpPr>
-          <p:cNvPr id="4" name="Slide Number Placeholder 3">
-            <a:extLst>
-              <a:ext uri="{FF2B5EF4-FFF2-40B4-BE49-F238E27FC236}">
-                <a16:creationId xmlns:a16="http://schemas.microsoft.com/office/drawing/2014/main" id="{1B63E5E3-796F-81C9-40E5-7338A8778418}"/>
-              </a:ext>
-            </a:extLst>
-          </p:cNvPr>
-          <p:cNvSpPr>
-            <a:spLocks noGrp="1"/>
-          </p:cNvSpPr>
-          <p:nvPr>
-            <p:ph type="sldNum" sz="quarter" idx="10"/>
-          </p:nvPr>
-        </p:nvSpPr>
-        <p:spPr/>
-        <p:txBody>
-          <a:bodyPr/>
-          <a:lstStyle/>
-          <a:p>
-            <a:fld id="{F7021451-1387-4CA6-816F-3879F97B5CBC}" type="slidenum">
-              <a:rPr lang="en-US"/>
-              <a:t>23</a:t>
-            </a:fld>
-            <a:endParaRPr lang="en-US"/>
-          </a:p>
-        </p:txBody>
-      </p:sp>
-    </p:spTree>
-    <p:extLst>
-      <p:ext uri="{BB962C8B-B14F-4D97-AF65-F5344CB8AC3E}">
-        <p14:creationId xmlns:p14="http://schemas.microsoft.com/office/powerpoint/2010/main" val="535062217"/>
+        <p14:creationId xmlns:p14="http://schemas.microsoft.com/office/powerpoint/2010/main" val="1024086991"/>
       </p:ext>
     </p:extLst>
   </p:cSld>
@@ -7670,13 +7839,6 @@
           </p:nvPr>
         </p:nvSpPr>
         <p:spPr/>
-        <p:txBody>
-          <a:bodyPr/>
-          <a:lstStyle/>
-          <a:p>
-            <a:endParaRPr lang="en-US"/>
-          </a:p>
-        </p:txBody>
       </p:sp>
       <p:sp>
         <p:nvSpPr>
@@ -7715,6 +7877,212 @@
             <a:fld id="{F7021451-1387-4CA6-816F-3879F97B5CBC}" type="slidenum">
               <a:rPr lang="en-US"/>
               <a:t>24</a:t>
+            </a:fld>
+            <a:endParaRPr lang="en-US"/>
+          </a:p>
+        </p:txBody>
+      </p:sp>
+    </p:spTree>
+    <p:extLst>
+      <p:ext uri="{BB962C8B-B14F-4D97-AF65-F5344CB8AC3E}">
+        <p14:creationId xmlns:p14="http://schemas.microsoft.com/office/powerpoint/2010/main" val="4054984044"/>
+      </p:ext>
+    </p:extLst>
+  </p:cSld>
+  <p:clrMapOvr>
+    <a:masterClrMapping/>
+  </p:clrMapOvr>
+</p:notes>
+</file>
+
+<file path=ppt/notesSlides/notesSlide16.xml><?xml version="1.0" encoding="utf-8"?>
+<p:notes xmlns:a="http://schemas.openxmlformats.org/drawingml/2006/main" xmlns:r="http://schemas.openxmlformats.org/officeDocument/2006/relationships" xmlns:p="http://schemas.openxmlformats.org/presentationml/2006/main">
+  <p:cSld>
+    <p:spTree>
+      <p:nvGrpSpPr>
+        <p:cNvPr id="1" name="">
+          <a:extLst>
+            <a:ext uri="{FF2B5EF4-FFF2-40B4-BE49-F238E27FC236}">
+              <a16:creationId xmlns:a16="http://schemas.microsoft.com/office/drawing/2014/main" id="{8AFC76FB-330B-AE8A-F590-349BD895D746}"/>
+            </a:ext>
+          </a:extLst>
+        </p:cNvPr>
+        <p:cNvGrpSpPr/>
+        <p:nvPr/>
+      </p:nvGrpSpPr>
+      <p:grpSpPr>
+        <a:xfrm>
+          <a:off x="0" y="0"/>
+          <a:ext cx="0" cy="0"/>
+          <a:chOff x="0" y="0"/>
+          <a:chExt cx="0" cy="0"/>
+        </a:xfrm>
+      </p:grpSpPr>
+      <p:sp>
+        <p:nvSpPr>
+          <p:cNvPr id="2" name="Slide Image Placeholder 1">
+            <a:extLst>
+              <a:ext uri="{FF2B5EF4-FFF2-40B4-BE49-F238E27FC236}">
+                <a16:creationId xmlns:a16="http://schemas.microsoft.com/office/drawing/2014/main" id="{D4F6FBFC-D2BC-59F9-2133-1EF554C92D81}"/>
+              </a:ext>
+            </a:extLst>
+          </p:cNvPr>
+          <p:cNvSpPr>
+            <a:spLocks noGrp="1" noRot="1" noChangeAspect="1"/>
+          </p:cNvSpPr>
+          <p:nvPr>
+            <p:ph type="sldImg"/>
+          </p:nvPr>
+        </p:nvSpPr>
+        <p:spPr/>
+        <p:txBody>
+          <a:bodyPr/>
+          <a:lstStyle/>
+          <a:p>
+            <a:endParaRPr lang="en-US"/>
+          </a:p>
+        </p:txBody>
+      </p:sp>
+      <p:sp>
+        <p:nvSpPr>
+          <p:cNvPr id="3" name="Notes Placeholder 2">
+            <a:extLst>
+              <a:ext uri="{FF2B5EF4-FFF2-40B4-BE49-F238E27FC236}">
+                <a16:creationId xmlns:a16="http://schemas.microsoft.com/office/drawing/2014/main" id="{97A65F92-03C7-0B2D-E9B5-578E1E5D861A}"/>
+              </a:ext>
+            </a:extLst>
+          </p:cNvPr>
+          <p:cNvSpPr>
+            <a:spLocks noGrp="1"/>
+          </p:cNvSpPr>
+          <p:nvPr>
+            <p:ph type="body" idx="1"/>
+          </p:nvPr>
+        </p:nvSpPr>
+        <p:spPr/>
+        <p:txBody>
+          <a:bodyPr/>
+          <a:lstStyle/>
+          <a:p>
+            <a:endParaRPr lang="en-US" dirty="0"/>
+          </a:p>
+        </p:txBody>
+      </p:sp>
+      <p:sp>
+        <p:nvSpPr>
+          <p:cNvPr id="4" name="Slide Number Placeholder 3">
+            <a:extLst>
+              <a:ext uri="{FF2B5EF4-FFF2-40B4-BE49-F238E27FC236}">
+                <a16:creationId xmlns:a16="http://schemas.microsoft.com/office/drawing/2014/main" id="{1B63E5E3-796F-81C9-40E5-7338A8778418}"/>
+              </a:ext>
+            </a:extLst>
+          </p:cNvPr>
+          <p:cNvSpPr>
+            <a:spLocks noGrp="1"/>
+          </p:cNvSpPr>
+          <p:nvPr>
+            <p:ph type="sldNum" sz="quarter" idx="10"/>
+          </p:nvPr>
+        </p:nvSpPr>
+        <p:spPr/>
+        <p:txBody>
+          <a:bodyPr/>
+          <a:lstStyle/>
+          <a:p>
+            <a:fld id="{F7021451-1387-4CA6-816F-3879F97B5CBC}" type="slidenum">
+              <a:rPr lang="en-US"/>
+              <a:t>25</a:t>
+            </a:fld>
+            <a:endParaRPr lang="en-US"/>
+          </a:p>
+        </p:txBody>
+      </p:sp>
+    </p:spTree>
+    <p:extLst>
+      <p:ext uri="{BB962C8B-B14F-4D97-AF65-F5344CB8AC3E}">
+        <p14:creationId xmlns:p14="http://schemas.microsoft.com/office/powerpoint/2010/main" val="535062217"/>
+      </p:ext>
+    </p:extLst>
+  </p:cSld>
+  <p:clrMapOvr>
+    <a:masterClrMapping/>
+  </p:clrMapOvr>
+</p:notes>
+</file>
+
+<file path=ppt/notesSlides/notesSlide17.xml><?xml version="1.0" encoding="utf-8"?>
+<p:notes xmlns:a="http://schemas.openxmlformats.org/drawingml/2006/main" xmlns:r="http://schemas.openxmlformats.org/officeDocument/2006/relationships" xmlns:p="http://schemas.openxmlformats.org/presentationml/2006/main">
+  <p:cSld>
+    <p:spTree>
+      <p:nvGrpSpPr>
+        <p:cNvPr id="1" name=""/>
+        <p:cNvGrpSpPr/>
+        <p:nvPr/>
+      </p:nvGrpSpPr>
+      <p:grpSpPr>
+        <a:xfrm>
+          <a:off x="0" y="0"/>
+          <a:ext cx="0" cy="0"/>
+          <a:chOff x="0" y="0"/>
+          <a:chExt cx="0" cy="0"/>
+        </a:xfrm>
+      </p:grpSpPr>
+      <p:sp>
+        <p:nvSpPr>
+          <p:cNvPr id="2" name="Slide Image Placeholder 1"/>
+          <p:cNvSpPr>
+            <a:spLocks noGrp="1" noRot="1" noChangeAspect="1"/>
+          </p:cNvSpPr>
+          <p:nvPr>
+            <p:ph type="sldImg"/>
+          </p:nvPr>
+        </p:nvSpPr>
+        <p:spPr/>
+        <p:txBody>
+          <a:bodyPr/>
+          <a:lstStyle/>
+          <a:p>
+            <a:endParaRPr lang="en-US"/>
+          </a:p>
+        </p:txBody>
+      </p:sp>
+      <p:sp>
+        <p:nvSpPr>
+          <p:cNvPr id="3" name="Notes Placeholder 2"/>
+          <p:cNvSpPr>
+            <a:spLocks noGrp="1"/>
+          </p:cNvSpPr>
+          <p:nvPr>
+            <p:ph type="body" idx="1"/>
+          </p:nvPr>
+        </p:nvSpPr>
+        <p:spPr/>
+        <p:txBody>
+          <a:bodyPr/>
+          <a:lstStyle/>
+          <a:p>
+            <a:endParaRPr lang="en-US" dirty="0"/>
+          </a:p>
+        </p:txBody>
+      </p:sp>
+      <p:sp>
+        <p:nvSpPr>
+          <p:cNvPr id="4" name="Slide Number Placeholder 3"/>
+          <p:cNvSpPr>
+            <a:spLocks noGrp="1"/>
+          </p:cNvSpPr>
+          <p:nvPr>
+            <p:ph type="sldNum" sz="quarter" idx="10"/>
+          </p:nvPr>
+        </p:nvSpPr>
+        <p:spPr/>
+        <p:txBody>
+          <a:bodyPr/>
+          <a:lstStyle/>
+          <a:p>
+            <a:fld id="{F7021451-1387-4CA6-816F-3879F97B5CBC}" type="slidenum">
+              <a:rPr lang="en-US"/>
+              <a:t>26</a:t>
             </a:fld>
             <a:endParaRPr lang="en-US"/>
           </a:p>
@@ -20130,13 +20498,7 @@
   <p:cSld>
     <p:spTree>
       <p:nvGrpSpPr>
-        <p:cNvPr id="1" name="">
-          <a:extLst>
-            <a:ext uri="{FF2B5EF4-FFF2-40B4-BE49-F238E27FC236}">
-              <a16:creationId xmlns:a16="http://schemas.microsoft.com/office/drawing/2014/main" id="{3E278A65-6CF0-1A9E-D226-632F4987A7A1}"/>
-            </a:ext>
-          </a:extLst>
-        </p:cNvPr>
+        <p:cNvPr id="1" name=""/>
         <p:cNvGrpSpPr/>
         <p:nvPr/>
       </p:nvGrpSpPr>
@@ -20150,97 +20512,512 @@
       </p:grpSpPr>
       <p:sp>
         <p:nvSpPr>
-          <p:cNvPr id="2" name="Title 1">
-            <a:extLst>
-              <a:ext uri="{FF2B5EF4-FFF2-40B4-BE49-F238E27FC236}">
-                <a16:creationId xmlns:a16="http://schemas.microsoft.com/office/drawing/2014/main" id="{DC398663-CAC8-9555-EB4E-7E738BD79D9F}"/>
-              </a:ext>
-            </a:extLst>
-          </p:cNvPr>
-          <p:cNvSpPr>
-            <a:spLocks noGrp="1"/>
-          </p:cNvSpPr>
-          <p:nvPr>
-            <p:ph type="title"/>
-          </p:nvPr>
-        </p:nvSpPr>
-        <p:spPr>
-          <a:xfrm>
-            <a:off x="359055" y="39083"/>
-            <a:ext cx="10515600" cy="1129992"/>
-          </a:xfrm>
-        </p:spPr>
-        <p:txBody>
-          <a:bodyPr>
+          <p:cNvPr id="2" name="Text 0"/>
+          <p:cNvSpPr/>
+          <p:nvPr/>
+        </p:nvSpPr>
+        <p:spPr>
+          <a:xfrm>
+            <a:off x="1962912" y="402336"/>
+            <a:ext cx="8138160" cy="384048"/>
+          </a:xfrm>
+          <a:prstGeom prst="rect">
+            <a:avLst/>
+          </a:prstGeom>
+          <a:noFill/>
+          <a:ln/>
+        </p:spPr>
+        <p:txBody>
+          <a:bodyPr wrap="square" lIns="0" tIns="0" rIns="0" bIns="0" rtlCol="0" anchor="ctr"/>
+          <a:lstStyle/>
+          <a:p>
+            <a:r>
+              <a:rPr lang="en-US" sz="2400" b="1" dirty="0">
+                <a:solidFill>
+                  <a:srgbClr val="122033"/>
+                </a:solidFill>
+                <a:latin typeface="Arial" pitchFamily="34" charset="0"/>
+                <a:ea typeface="Arial" pitchFamily="34" charset="-122"/>
+                <a:cs typeface="Arial" pitchFamily="34" charset="-120"/>
+              </a:rPr>
+              <a:t>Sprint Plan</a:t>
+            </a:r>
+            <a:endParaRPr lang="en-US" sz="2400" dirty="0"/>
+          </a:p>
+        </p:txBody>
+      </p:sp>
+      <p:sp>
+        <p:nvSpPr>
+          <p:cNvPr id="3" name="Text 1"/>
+          <p:cNvSpPr/>
+          <p:nvPr/>
+        </p:nvSpPr>
+        <p:spPr>
+          <a:xfrm>
+            <a:off x="1981200" y="859536"/>
+            <a:ext cx="7955280" cy="256032"/>
+          </a:xfrm>
+          <a:prstGeom prst="rect">
+            <a:avLst/>
+          </a:prstGeom>
+          <a:noFill/>
+          <a:ln/>
+        </p:spPr>
+        <p:txBody>
+          <a:bodyPr wrap="square" lIns="0" tIns="0" rIns="0" bIns="0" rtlCol="0" anchor="ctr"/>
+          <a:lstStyle/>
+          <a:p>
+            <a:r>
+              <a:rPr lang="en-US" sz="1400" dirty="0">
+                <a:solidFill>
+                  <a:srgbClr val="5B667A"/>
+                </a:solidFill>
+                <a:latin typeface="Arial" pitchFamily="34" charset="0"/>
+                <a:ea typeface="Arial" pitchFamily="34" charset="-122"/>
+                <a:cs typeface="Arial" pitchFamily="34" charset="-120"/>
+              </a:rPr>
+              <a:t>How Stage 2 will convert the Stage 1 design and Postman PoC into a working test harness</a:t>
+            </a:r>
+            <a:endParaRPr lang="en-US" sz="1400" dirty="0"/>
+          </a:p>
+        </p:txBody>
+      </p:sp>
+      <p:sp>
+        <p:nvSpPr>
+          <p:cNvPr id="4" name="Shape 2"/>
+          <p:cNvSpPr/>
+          <p:nvPr/>
+        </p:nvSpPr>
+        <p:spPr>
+          <a:xfrm>
+            <a:off x="1962912" y="1234440"/>
+            <a:ext cx="8275320" cy="54864"/>
+          </a:xfrm>
+          <a:prstGeom prst="rect">
+            <a:avLst/>
+          </a:prstGeom>
+          <a:solidFill>
+            <a:srgbClr val="182354"/>
+          </a:solidFill>
+          <a:ln w="12700">
+            <a:solidFill>
+              <a:srgbClr val="182354"/>
+            </a:solidFill>
+            <a:prstDash val="solid"/>
+          </a:ln>
+        </p:spPr>
+        <p:txBody>
+          <a:bodyPr/>
+          <a:lstStyle/>
+          <a:p>
+            <a:endParaRPr lang="en-US"/>
+          </a:p>
+        </p:txBody>
+      </p:sp>
+      <p:sp>
+        <p:nvSpPr>
+          <p:cNvPr id="5" name="Shape 3"/>
+          <p:cNvSpPr/>
+          <p:nvPr/>
+        </p:nvSpPr>
+        <p:spPr>
+          <a:xfrm>
+            <a:off x="2054352" y="1508760"/>
+            <a:ext cx="3886200" cy="3611880"/>
+          </a:xfrm>
+          <a:prstGeom prst="roundRect">
+            <a:avLst>
+              <a:gd name="adj" fmla="val 1519"/>
+            </a:avLst>
+          </a:prstGeom>
+          <a:solidFill>
+            <a:srgbClr val="F4F6FB"/>
+          </a:solidFill>
+          <a:ln w="12700">
+            <a:solidFill>
+              <a:srgbClr val="DCE3F3">
+                <a:alpha val="92000"/>
+              </a:srgbClr>
+            </a:solidFill>
+            <a:prstDash val="solid"/>
+          </a:ln>
+        </p:spPr>
+        <p:txBody>
+          <a:bodyPr/>
+          <a:lstStyle/>
+          <a:p>
+            <a:endParaRPr lang="en-US" sz="1400"/>
+          </a:p>
+        </p:txBody>
+      </p:sp>
+      <p:sp>
+        <p:nvSpPr>
+          <p:cNvPr id="6" name="Shape 4"/>
+          <p:cNvSpPr/>
+          <p:nvPr/>
+        </p:nvSpPr>
+        <p:spPr>
+          <a:xfrm>
+            <a:off x="6260592" y="1508760"/>
+            <a:ext cx="3886200" cy="3611880"/>
+          </a:xfrm>
+          <a:prstGeom prst="roundRect">
+            <a:avLst>
+              <a:gd name="adj" fmla="val 1519"/>
+            </a:avLst>
+          </a:prstGeom>
+          <a:solidFill>
+            <a:srgbClr val="F4F6FB"/>
+          </a:solidFill>
+          <a:ln w="12700">
+            <a:solidFill>
+              <a:srgbClr val="DCE3F3">
+                <a:alpha val="92000"/>
+              </a:srgbClr>
+            </a:solidFill>
+            <a:prstDash val="solid"/>
+          </a:ln>
+        </p:spPr>
+        <p:txBody>
+          <a:bodyPr/>
+          <a:lstStyle/>
+          <a:p>
+            <a:endParaRPr lang="en-US" sz="1400"/>
+          </a:p>
+        </p:txBody>
+      </p:sp>
+      <p:sp>
+        <p:nvSpPr>
+          <p:cNvPr id="7" name="Shape 5"/>
+          <p:cNvSpPr/>
+          <p:nvPr/>
+        </p:nvSpPr>
+        <p:spPr>
+          <a:xfrm>
+            <a:off x="2273808" y="1728216"/>
+            <a:ext cx="868680" cy="228600"/>
+          </a:xfrm>
+          <a:prstGeom prst="roundRect">
+            <a:avLst>
+              <a:gd name="adj" fmla="val 28000"/>
+            </a:avLst>
+          </a:prstGeom>
+          <a:solidFill>
+            <a:srgbClr val="182354"/>
+          </a:solidFill>
+          <a:ln w="12700">
+            <a:solidFill>
+              <a:srgbClr val="182354"/>
+            </a:solidFill>
+            <a:prstDash val="solid"/>
+          </a:ln>
+        </p:spPr>
+        <p:txBody>
+          <a:bodyPr/>
+          <a:lstStyle/>
+          <a:p>
+            <a:endParaRPr lang="en-US" sz="1400"/>
+          </a:p>
+        </p:txBody>
+      </p:sp>
+      <p:sp>
+        <p:nvSpPr>
+          <p:cNvPr id="8" name="Text 6"/>
+          <p:cNvSpPr/>
+          <p:nvPr/>
+        </p:nvSpPr>
+        <p:spPr>
+          <a:xfrm>
+            <a:off x="2346960" y="1778508"/>
+            <a:ext cx="722376" cy="109728"/>
+          </a:xfrm>
+          <a:prstGeom prst="rect">
+            <a:avLst/>
+          </a:prstGeom>
+          <a:noFill/>
+          <a:ln/>
+        </p:spPr>
+        <p:txBody>
+          <a:bodyPr wrap="square" lIns="0" tIns="0" rIns="0" bIns="0" rtlCol="0" anchor="ctr"/>
+          <a:lstStyle/>
+          <a:p>
+            <a:pPr algn="ctr"/>
+            <a:r>
+              <a:rPr lang="en-US" sz="1200" b="1" dirty="0">
+                <a:solidFill>
+                  <a:srgbClr val="FFFFFF"/>
+                </a:solidFill>
+                <a:latin typeface="Arial" pitchFamily="34" charset="0"/>
+                <a:ea typeface="Arial" pitchFamily="34" charset="-122"/>
+                <a:cs typeface="Arial" pitchFamily="34" charset="-120"/>
+              </a:rPr>
+              <a:t>SPRINT 1</a:t>
+            </a:r>
+            <a:endParaRPr lang="en-US" sz="1200" dirty="0"/>
+          </a:p>
+        </p:txBody>
+      </p:sp>
+      <p:sp>
+        <p:nvSpPr>
+          <p:cNvPr id="9" name="Shape 7"/>
+          <p:cNvSpPr/>
+          <p:nvPr/>
+        </p:nvSpPr>
+        <p:spPr>
+          <a:xfrm>
+            <a:off x="6480048" y="1728216"/>
+            <a:ext cx="868680" cy="228600"/>
+          </a:xfrm>
+          <a:prstGeom prst="roundRect">
+            <a:avLst>
+              <a:gd name="adj" fmla="val 28000"/>
+            </a:avLst>
+          </a:prstGeom>
+          <a:solidFill>
+            <a:srgbClr val="182354"/>
+          </a:solidFill>
+          <a:ln w="12700">
+            <a:solidFill>
+              <a:srgbClr val="182354"/>
+            </a:solidFill>
+            <a:prstDash val="solid"/>
+          </a:ln>
+        </p:spPr>
+        <p:txBody>
+          <a:bodyPr/>
+          <a:lstStyle/>
+          <a:p>
+            <a:endParaRPr lang="en-US" sz="1400"/>
+          </a:p>
+        </p:txBody>
+      </p:sp>
+      <p:sp>
+        <p:nvSpPr>
+          <p:cNvPr id="10" name="Text 8"/>
+          <p:cNvSpPr/>
+          <p:nvPr/>
+        </p:nvSpPr>
+        <p:spPr>
+          <a:xfrm>
+            <a:off x="6553200" y="1778508"/>
+            <a:ext cx="722376" cy="109728"/>
+          </a:xfrm>
+          <a:prstGeom prst="rect">
+            <a:avLst/>
+          </a:prstGeom>
+          <a:noFill/>
+          <a:ln/>
+        </p:spPr>
+        <p:txBody>
+          <a:bodyPr wrap="square" lIns="0" tIns="0" rIns="0" bIns="0" rtlCol="0" anchor="ctr"/>
+          <a:lstStyle/>
+          <a:p>
+            <a:pPr algn="ctr"/>
+            <a:r>
+              <a:rPr lang="en-US" sz="1200" b="1" dirty="0">
+                <a:solidFill>
+                  <a:srgbClr val="FFFFFF"/>
+                </a:solidFill>
+                <a:latin typeface="Arial" pitchFamily="34" charset="0"/>
+                <a:ea typeface="Arial" pitchFamily="34" charset="-122"/>
+                <a:cs typeface="Arial" pitchFamily="34" charset="-120"/>
+              </a:rPr>
+              <a:t>SPRINT 2</a:t>
+            </a:r>
+            <a:endParaRPr lang="en-US" sz="1200" dirty="0"/>
+          </a:p>
+        </p:txBody>
+      </p:sp>
+      <p:sp>
+        <p:nvSpPr>
+          <p:cNvPr id="11" name="Text 9"/>
+          <p:cNvSpPr/>
+          <p:nvPr/>
+        </p:nvSpPr>
+        <p:spPr>
+          <a:xfrm>
+            <a:off x="2273808" y="2011680"/>
+            <a:ext cx="3337560" cy="256032"/>
+          </a:xfrm>
+          <a:prstGeom prst="rect">
+            <a:avLst/>
+          </a:prstGeom>
+          <a:noFill/>
+          <a:ln/>
+        </p:spPr>
+        <p:txBody>
+          <a:bodyPr wrap="square" lIns="0" tIns="0" rIns="0" bIns="0" rtlCol="0" anchor="ctr"/>
+          <a:lstStyle/>
+          <a:p>
+            <a:r>
+              <a:rPr lang="en-US" sz="1400" b="1" dirty="0">
+                <a:solidFill>
+                  <a:srgbClr val="122033"/>
+                </a:solidFill>
+                <a:latin typeface="Arial" pitchFamily="34" charset="0"/>
+                <a:ea typeface="Arial" pitchFamily="34" charset="-122"/>
+                <a:cs typeface="Arial" pitchFamily="34" charset="-120"/>
+              </a:rPr>
+              <a:t>Core Test Harness Foundation</a:t>
+            </a:r>
+            <a:endParaRPr lang="en-US" sz="1400" dirty="0"/>
+          </a:p>
+        </p:txBody>
+      </p:sp>
+      <p:sp>
+        <p:nvSpPr>
+          <p:cNvPr id="12" name="Text 10"/>
+          <p:cNvSpPr/>
+          <p:nvPr/>
+        </p:nvSpPr>
+        <p:spPr>
+          <a:xfrm>
+            <a:off x="6480048" y="2011680"/>
+            <a:ext cx="3337560" cy="256032"/>
+          </a:xfrm>
+          <a:prstGeom prst="rect">
+            <a:avLst/>
+          </a:prstGeom>
+          <a:noFill/>
+          <a:ln/>
+        </p:spPr>
+        <p:txBody>
+          <a:bodyPr wrap="square" lIns="0" tIns="0" rIns="0" bIns="0" rtlCol="0" anchor="ctr"/>
+          <a:lstStyle/>
+          <a:p>
+            <a:r>
+              <a:rPr lang="en-US" sz="1400" b="1" dirty="0">
+                <a:solidFill>
+                  <a:srgbClr val="122033"/>
+                </a:solidFill>
+                <a:latin typeface="Arial" pitchFamily="34" charset="0"/>
+                <a:ea typeface="Arial" pitchFamily="34" charset="-122"/>
+                <a:cs typeface="Arial" pitchFamily="34" charset="-120"/>
+              </a:rPr>
+              <a:t>Integration, Security &amp; Validation</a:t>
+            </a:r>
+            <a:endParaRPr lang="en-US" sz="1400" dirty="0"/>
+          </a:p>
+        </p:txBody>
+      </p:sp>
+      <p:sp>
+        <p:nvSpPr>
+          <p:cNvPr id="13" name="Text 11"/>
+          <p:cNvSpPr/>
+          <p:nvPr/>
+        </p:nvSpPr>
+        <p:spPr>
+          <a:xfrm>
+            <a:off x="2273808" y="2450592"/>
+            <a:ext cx="3383280" cy="1783080"/>
+          </a:xfrm>
+          <a:prstGeom prst="rect">
+            <a:avLst/>
+          </a:prstGeom>
+          <a:noFill/>
+          <a:ln/>
+        </p:spPr>
+        <p:txBody>
+          <a:bodyPr wrap="square" lIns="254" tIns="254" rIns="254" bIns="254" rtlCol="0" anchor="ctr">
             <a:normAutofit/>
           </a:bodyPr>
           <a:lstStyle/>
           <a:p>
-            <a:pPr algn="just"/>
-            <a:r>
-              <a:rPr lang="en-US" sz="3500" b="1" dirty="0">
+            <a:r>
+              <a:rPr lang="en-US" sz="1400" dirty="0">
                 <a:solidFill>
-                  <a:schemeClr val="tx2"/>
+                  <a:srgbClr val="394255"/>
                 </a:solidFill>
-                <a:latin typeface="Calibri" panose="020F0502020204030204" pitchFamily="34" charset="0"/>
-                <a:ea typeface="Calibri" panose="020F0502020204030204" pitchFamily="34" charset="0"/>
-                <a:cs typeface="Calibri" panose="020F0502020204030204" pitchFamily="34" charset="0"/>
+                <a:latin typeface="Arial" pitchFamily="34" charset="0"/>
+                <a:ea typeface="Arial" pitchFamily="34" charset="-122"/>
+                <a:cs typeface="Arial" pitchFamily="34" charset="-120"/>
               </a:rPr>
-              <a:t>Proof of Concept, Testing and Cybersecurity Evaluation</a:t>
-            </a:r>
-          </a:p>
-        </p:txBody>
-      </p:sp>
-      <p:sp>
-        <p:nvSpPr>
-          <p:cNvPr id="6" name="TextBox 5">
-            <a:extLst>
-              <a:ext uri="{FF2B5EF4-FFF2-40B4-BE49-F238E27FC236}">
-                <a16:creationId xmlns:a16="http://schemas.microsoft.com/office/drawing/2014/main" id="{F2785A4F-40E6-A1BA-F3F8-DC1FD5027CF6}"/>
-              </a:ext>
-            </a:extLst>
-          </p:cNvPr>
-          <p:cNvSpPr txBox="1"/>
-          <p:nvPr/>
-        </p:nvSpPr>
-        <p:spPr>
-          <a:xfrm>
-            <a:off x="350520" y="1089355"/>
-            <a:ext cx="11255045" cy="1785519"/>
-          </a:xfrm>
-          <a:prstGeom prst="rect">
-            <a:avLst/>
-          </a:prstGeom>
-          <a:solidFill>
-            <a:srgbClr val="F4F7FD"/>
-          </a:solidFill>
-        </p:spPr>
-        <p:txBody>
-          <a:bodyPr wrap="square" rtlCol="0">
-            <a:spAutoFit/>
-          </a:bodyPr>
-          <a:lstStyle/>
-          <a:p>
-            <a:endParaRPr lang="en-AU" dirty="0"/>
-          </a:p>
-        </p:txBody>
-      </p:sp>
-      <p:sp>
-        <p:nvSpPr>
-          <p:cNvPr id="10" name="Text 4">
-            <a:extLst>
-              <a:ext uri="{FF2B5EF4-FFF2-40B4-BE49-F238E27FC236}">
-                <a16:creationId xmlns:a16="http://schemas.microsoft.com/office/drawing/2014/main" id="{7D8DE7F3-444E-D654-CF78-C5AE123A96C4}"/>
-              </a:ext>
-            </a:extLst>
-          </p:cNvPr>
-          <p:cNvSpPr txBox="1"/>
-          <p:nvPr/>
-        </p:nvSpPr>
-        <p:spPr>
-          <a:xfrm>
-            <a:off x="586435" y="1303626"/>
-            <a:ext cx="822960" cy="1170432"/>
+              <a:t>• Confirm backend framework and standards</a:t>
+            </a:r>
+            <a:endParaRPr lang="en-US" sz="1400" dirty="0"/>
+          </a:p>
+          <a:p>
+            <a:r>
+              <a:rPr lang="en-US" sz="1400" dirty="0">
+                <a:solidFill>
+                  <a:srgbClr val="394255"/>
+                </a:solidFill>
+                <a:latin typeface="Arial" pitchFamily="34" charset="0"/>
+                <a:ea typeface="Arial" pitchFamily="34" charset="-122"/>
+                <a:cs typeface="Arial" pitchFamily="34" charset="-120"/>
+              </a:rPr>
+              <a:t>• Configure Docker Compose environment</a:t>
+            </a:r>
+            <a:endParaRPr lang="en-US" sz="1400" dirty="0"/>
+          </a:p>
+          <a:p>
+            <a:r>
+              <a:rPr lang="en-US" sz="1400" dirty="0">
+                <a:solidFill>
+                  <a:srgbClr val="394255"/>
+                </a:solidFill>
+                <a:latin typeface="Arial" pitchFamily="34" charset="0"/>
+                <a:ea typeface="Arial" pitchFamily="34" charset="-122"/>
+                <a:cs typeface="Arial" pitchFamily="34" charset="-120"/>
+              </a:rPr>
+              <a:t>• Build Test Harness API + Patient workflow</a:t>
+            </a:r>
+            <a:endParaRPr lang="en-US" sz="1400" dirty="0"/>
+          </a:p>
+          <a:p>
+            <a:r>
+              <a:rPr lang="en-US" sz="1400" dirty="0">
+                <a:solidFill>
+                  <a:srgbClr val="394255"/>
+                </a:solidFill>
+                <a:latin typeface="Arial" pitchFamily="34" charset="0"/>
+                <a:ea typeface="Arial" pitchFamily="34" charset="-122"/>
+                <a:cs typeface="Arial" pitchFamily="34" charset="-120"/>
+              </a:rPr>
+              <a:t>• Set up PostgreSQL synthetic-data store</a:t>
+            </a:r>
+            <a:endParaRPr lang="en-US" sz="1400" dirty="0"/>
+          </a:p>
+          <a:p>
+            <a:r>
+              <a:rPr lang="en-US" sz="1400" dirty="0">
+                <a:solidFill>
+                  <a:srgbClr val="394255"/>
+                </a:solidFill>
+                <a:latin typeface="Arial" pitchFamily="34" charset="0"/>
+                <a:ea typeface="Arial" pitchFamily="34" charset="-122"/>
+                <a:cs typeface="Arial" pitchFamily="34" charset="-120"/>
+              </a:rPr>
+              <a:t>• Connect HAPI FHIR validation service</a:t>
+            </a:r>
+            <a:endParaRPr lang="en-US" sz="1400" dirty="0"/>
+          </a:p>
+          <a:p>
+            <a:r>
+              <a:rPr lang="en-US" sz="1400" dirty="0">
+                <a:solidFill>
+                  <a:srgbClr val="394255"/>
+                </a:solidFill>
+                <a:latin typeface="Arial" pitchFamily="34" charset="0"/>
+                <a:ea typeface="Arial" pitchFamily="34" charset="-122"/>
+                <a:cs typeface="Arial" pitchFamily="34" charset="-120"/>
+              </a:rPr>
+              <a:t>• Create automated test scaffold</a:t>
+            </a:r>
+            <a:endParaRPr lang="en-US" sz="1400" dirty="0"/>
+          </a:p>
+        </p:txBody>
+      </p:sp>
+      <p:sp>
+        <p:nvSpPr>
+          <p:cNvPr id="14" name="Text 12"/>
+          <p:cNvSpPr/>
+          <p:nvPr/>
+        </p:nvSpPr>
+        <p:spPr>
+          <a:xfrm>
+            <a:off x="6480048" y="2450592"/>
+            <a:ext cx="3383280" cy="1920240"/>
           </a:xfrm>
           <a:prstGeom prst="rect">
             <a:avLst/>
@@ -20249,40 +21026,140 @@
           <a:ln/>
         </p:spPr>
         <p:txBody>
-          <a:bodyPr wrap="square" lIns="0" tIns="0" rIns="0" bIns="0" rtlCol="0" anchor="t"/>
-          <a:lstStyle/>
-          <a:p>
-            <a:pPr marL="0" indent="0" algn="just">
-              <a:buNone/>
-            </a:pPr>
-            <a:r>
-              <a:rPr lang="en-US" sz="2400" b="1" dirty="0">
-                <a:latin typeface="Cambria" pitchFamily="34" charset="0"/>
-                <a:ea typeface="Cambria" pitchFamily="34" charset="-122"/>
-                <a:cs typeface="Cambria" pitchFamily="34" charset="-120"/>
+          <a:bodyPr wrap="square" lIns="254" tIns="254" rIns="254" bIns="254" rtlCol="0" anchor="ctr">
+            <a:noAutofit/>
+          </a:bodyPr>
+          <a:lstStyle/>
+          <a:p>
+            <a:r>
+              <a:rPr lang="en-US" sz="1400" dirty="0">
+                <a:solidFill>
+                  <a:srgbClr val="394255"/>
+                </a:solidFill>
+                <a:latin typeface="Arial" pitchFamily="34" charset="0"/>
+                <a:ea typeface="Arial" pitchFamily="34" charset="-122"/>
+                <a:cs typeface="Arial" pitchFamily="34" charset="-120"/>
               </a:rPr>
-              <a:t>01</a:t>
-            </a:r>
-            <a:endParaRPr lang="en-US" sz="2400" dirty="0"/>
-          </a:p>
-        </p:txBody>
-      </p:sp>
-      <p:sp>
-        <p:nvSpPr>
-          <p:cNvPr id="16" name="Text 5">
-            <a:extLst>
-              <a:ext uri="{FF2B5EF4-FFF2-40B4-BE49-F238E27FC236}">
-                <a16:creationId xmlns:a16="http://schemas.microsoft.com/office/drawing/2014/main" id="{E519C6E1-0695-0AD2-CB76-A084E34A8410}"/>
-              </a:ext>
-            </a:extLst>
-          </p:cNvPr>
-          <p:cNvSpPr txBox="1"/>
-          <p:nvPr/>
-        </p:nvSpPr>
-        <p:spPr>
-          <a:xfrm>
-            <a:off x="1221435" y="1282290"/>
-            <a:ext cx="6126480" cy="365760"/>
+              <a:t>• Execute seven failure-mode test cases</a:t>
+            </a:r>
+            <a:endParaRPr lang="en-US" sz="1400" dirty="0"/>
+          </a:p>
+          <a:p>
+            <a:r>
+              <a:rPr lang="en-US" sz="1400" dirty="0">
+                <a:solidFill>
+                  <a:srgbClr val="394255"/>
+                </a:solidFill>
+                <a:latin typeface="Arial" pitchFamily="34" charset="0"/>
+                <a:ea typeface="Arial" pitchFamily="34" charset="-122"/>
+                <a:cs typeface="Arial" pitchFamily="34" charset="-120"/>
+              </a:rPr>
+              <a:t>• Add slow, malformed, dropped and unavailable simulations</a:t>
+            </a:r>
+            <a:endParaRPr lang="en-US" sz="1400" dirty="0"/>
+          </a:p>
+          <a:p>
+            <a:r>
+              <a:rPr lang="en-US" sz="1400" dirty="0">
+                <a:solidFill>
+                  <a:srgbClr val="394255"/>
+                </a:solidFill>
+                <a:latin typeface="Arial" pitchFamily="34" charset="0"/>
+                <a:ea typeface="Arial" pitchFamily="34" charset="-122"/>
+                <a:cs typeface="Arial" pitchFamily="34" charset="-120"/>
+              </a:rPr>
+              <a:t>• Implement auth, RBAC and tenant isolation</a:t>
+            </a:r>
+            <a:endParaRPr lang="en-US" sz="1400" dirty="0"/>
+          </a:p>
+          <a:p>
+            <a:r>
+              <a:rPr lang="en-US" sz="1400" dirty="0">
+                <a:solidFill>
+                  <a:srgbClr val="394255"/>
+                </a:solidFill>
+                <a:latin typeface="Arial" pitchFamily="34" charset="0"/>
+                <a:ea typeface="Arial" pitchFamily="34" charset="-122"/>
+                <a:cs typeface="Arial" pitchFamily="34" charset="-120"/>
+              </a:rPr>
+              <a:t>• Validate SNOMED CT-AU → ICD-10-AM/MBS mappings</a:t>
+            </a:r>
+            <a:endParaRPr lang="en-US" sz="1400" dirty="0"/>
+          </a:p>
+          <a:p>
+            <a:r>
+              <a:rPr lang="en-US" sz="1400" dirty="0">
+                <a:solidFill>
+                  <a:srgbClr val="394255"/>
+                </a:solidFill>
+                <a:latin typeface="Arial" pitchFamily="34" charset="0"/>
+                <a:ea typeface="Arial" pitchFamily="34" charset="-122"/>
+                <a:cs typeface="Arial" pitchFamily="34" charset="-120"/>
+              </a:rPr>
+              <a:t>• Develop React scenario/results interface</a:t>
+            </a:r>
+            <a:endParaRPr lang="en-US" sz="1400" dirty="0"/>
+          </a:p>
+          <a:p>
+            <a:r>
+              <a:rPr lang="en-US" sz="1400" dirty="0">
+                <a:solidFill>
+                  <a:srgbClr val="394255"/>
+                </a:solidFill>
+                <a:latin typeface="Arial" pitchFamily="34" charset="0"/>
+                <a:ea typeface="Arial" pitchFamily="34" charset="-122"/>
+                <a:cs typeface="Arial" pitchFamily="34" charset="-120"/>
+              </a:rPr>
+              <a:t>• Produce test report and regression evidence</a:t>
+            </a:r>
+            <a:endParaRPr lang="en-US" sz="1400" dirty="0"/>
+          </a:p>
+        </p:txBody>
+      </p:sp>
+      <p:sp>
+        <p:nvSpPr>
+          <p:cNvPr id="15" name="Shape 13"/>
+          <p:cNvSpPr/>
+          <p:nvPr/>
+        </p:nvSpPr>
+        <p:spPr>
+          <a:xfrm>
+            <a:off x="2054352" y="5376672"/>
+            <a:ext cx="8092440" cy="658368"/>
+          </a:xfrm>
+          <a:prstGeom prst="roundRect">
+            <a:avLst>
+              <a:gd name="adj" fmla="val 6944"/>
+            </a:avLst>
+          </a:prstGeom>
+          <a:solidFill>
+            <a:srgbClr val="182354"/>
+          </a:solidFill>
+          <a:ln w="12700">
+            <a:solidFill>
+              <a:srgbClr val="182354"/>
+            </a:solidFill>
+            <a:prstDash val="solid"/>
+          </a:ln>
+        </p:spPr>
+        <p:txBody>
+          <a:bodyPr/>
+          <a:lstStyle/>
+          <a:p>
+            <a:endParaRPr lang="en-US" sz="1400"/>
+          </a:p>
+        </p:txBody>
+      </p:sp>
+      <p:sp>
+        <p:nvSpPr>
+          <p:cNvPr id="16" name="Text 14"/>
+          <p:cNvSpPr/>
+          <p:nvPr/>
+        </p:nvSpPr>
+        <p:spPr>
+          <a:xfrm>
+            <a:off x="2310384" y="5532120"/>
+            <a:ext cx="7589520" cy="274320"/>
           </a:xfrm>
           <a:prstGeom prst="rect">
             <a:avLst/>
@@ -20291,37 +21168,37 @@
           <a:ln/>
         </p:spPr>
         <p:txBody>
-          <a:bodyPr wrap="square" lIns="0" tIns="0" rIns="0" bIns="0" rtlCol="0" anchor="ctr"/>
-          <a:lstStyle/>
-          <a:p>
-            <a:pPr algn="just"/>
-            <a:r>
-              <a:rPr lang="en-US" sz="2400" b="1" dirty="0">
-                <a:latin typeface="Calibri" panose="020F0502020204030204" pitchFamily="34" charset="0"/>
-                <a:ea typeface="Calibri" panose="020F0502020204030204" pitchFamily="34" charset="0"/>
-                <a:cs typeface="Calibri" panose="020F0502020204030204" pitchFamily="34" charset="0"/>
+          <a:bodyPr wrap="square" lIns="0" tIns="0" rIns="0" bIns="0" rtlCol="0" anchor="ctr">
+            <a:noAutofit/>
+          </a:bodyPr>
+          <a:lstStyle/>
+          <a:p>
+            <a:pPr algn="ctr"/>
+            <a:r>
+              <a:rPr lang="en-US" sz="1400" b="1" dirty="0">
+                <a:solidFill>
+                  <a:srgbClr val="FFFFFF"/>
+                </a:solidFill>
+                <a:latin typeface="Arial" pitchFamily="34" charset="0"/>
+                <a:ea typeface="Arial" pitchFamily="34" charset="-122"/>
+                <a:cs typeface="Arial" pitchFamily="34" charset="-120"/>
               </a:rPr>
-              <a:t>Working Proof of Concept</a:t>
-            </a:r>
-          </a:p>
-        </p:txBody>
-      </p:sp>
-      <p:sp>
-        <p:nvSpPr>
-          <p:cNvPr id="18" name="Text 6">
-            <a:extLst>
-              <a:ext uri="{FF2B5EF4-FFF2-40B4-BE49-F238E27FC236}">
-                <a16:creationId xmlns:a16="http://schemas.microsoft.com/office/drawing/2014/main" id="{0D55470B-E2B6-6833-56B6-194FF1AD5C5F}"/>
-              </a:ext>
-            </a:extLst>
-          </p:cNvPr>
-          <p:cNvSpPr txBox="1"/>
-          <p:nvPr/>
-        </p:nvSpPr>
-        <p:spPr>
-          <a:xfrm>
-            <a:off x="1221434" y="1863825"/>
-            <a:ext cx="9736735" cy="640080"/>
+              <a:t>Stage 1 has delivered the architecture, planned tests and a limited Postman PoC. ICT946 will implement and test the complete harness incrementally.</a:t>
+            </a:r>
+            <a:endParaRPr lang="en-US" sz="1400" dirty="0"/>
+          </a:p>
+        </p:txBody>
+      </p:sp>
+      <p:sp>
+        <p:nvSpPr>
+          <p:cNvPr id="17" name="Text 15"/>
+          <p:cNvSpPr/>
+          <p:nvPr/>
+        </p:nvSpPr>
+        <p:spPr>
+          <a:xfrm>
+            <a:off x="9936480" y="6510528"/>
+            <a:ext cx="457200" cy="164592"/>
           </a:xfrm>
           <a:prstGeom prst="rect">
             <a:avLst/>
@@ -20333,326 +21210,23 @@
           <a:bodyPr wrap="square" lIns="0" tIns="0" rIns="0" bIns="0" rtlCol="0" anchor="ctr"/>
           <a:lstStyle/>
           <a:p>
-            <a:r>
-              <a:rPr lang="en-US" sz="2000" dirty="0"/>
-              <a:t>I configured a synthetic FHIR R4 Patient mock endpoint in Postman that responds to GET /</a:t>
-            </a:r>
-            <a:r>
-              <a:rPr lang="en-US" sz="2000" dirty="0" err="1"/>
-              <a:t>fhir</a:t>
-            </a:r>
-            <a:r>
-              <a:rPr lang="en-US" sz="2000" dirty="0"/>
-              <a:t>/R4/Patient/SYNTH-001 with a synthetic Patient resource and HTTP 200 OK.</a:t>
-            </a:r>
-          </a:p>
-        </p:txBody>
-      </p:sp>
-      <p:sp>
-        <p:nvSpPr>
-          <p:cNvPr id="20" name="TextBox 19">
-            <a:extLst>
-              <a:ext uri="{FF2B5EF4-FFF2-40B4-BE49-F238E27FC236}">
-                <a16:creationId xmlns:a16="http://schemas.microsoft.com/office/drawing/2014/main" id="{97B7CCC5-38B6-5581-91AF-4DF4BE5242AB}"/>
-              </a:ext>
-            </a:extLst>
-          </p:cNvPr>
-          <p:cNvSpPr txBox="1"/>
-          <p:nvPr/>
-        </p:nvSpPr>
-        <p:spPr>
-          <a:xfrm>
-            <a:off x="347676" y="2988090"/>
-            <a:ext cx="11255045" cy="1722900"/>
-          </a:xfrm>
-          <a:prstGeom prst="rect">
-            <a:avLst/>
-          </a:prstGeom>
-          <a:solidFill>
-            <a:srgbClr val="F4F7FD"/>
-          </a:solidFill>
-        </p:spPr>
-        <p:txBody>
-          <a:bodyPr wrap="square" rtlCol="0">
-            <a:spAutoFit/>
-          </a:bodyPr>
-          <a:lstStyle/>
-          <a:p>
-            <a:endParaRPr lang="en-AU" dirty="0"/>
-          </a:p>
-        </p:txBody>
-      </p:sp>
-      <p:sp>
-        <p:nvSpPr>
-          <p:cNvPr id="22" name="Text 8">
-            <a:extLst>
-              <a:ext uri="{FF2B5EF4-FFF2-40B4-BE49-F238E27FC236}">
-                <a16:creationId xmlns:a16="http://schemas.microsoft.com/office/drawing/2014/main" id="{0B13388C-6D0C-309F-D29C-B815BD090CA6}"/>
-              </a:ext>
-            </a:extLst>
-          </p:cNvPr>
-          <p:cNvSpPr txBox="1"/>
-          <p:nvPr/>
-        </p:nvSpPr>
-        <p:spPr>
-          <a:xfrm>
-            <a:off x="542339" y="3133206"/>
-            <a:ext cx="1213993" cy="1170432"/>
-          </a:xfrm>
-          <a:prstGeom prst="rect">
-            <a:avLst/>
-          </a:prstGeom>
-          <a:noFill/>
-          <a:ln/>
-        </p:spPr>
-        <p:txBody>
-          <a:bodyPr wrap="square" lIns="0" tIns="0" rIns="0" bIns="0" rtlCol="0" anchor="t"/>
-          <a:lstStyle/>
-          <a:p>
-            <a:pPr marL="0" indent="0" algn="just">
-              <a:buNone/>
-            </a:pPr>
-            <a:r>
-              <a:rPr lang="en-US" sz="2400" b="1" dirty="0">
-                <a:latin typeface="Cambria" pitchFamily="34" charset="0"/>
-                <a:ea typeface="Cambria" pitchFamily="34" charset="-122"/>
-                <a:cs typeface="Cambria" pitchFamily="34" charset="-120"/>
+            <a:pPr algn="r"/>
+            <a:r>
+              <a:rPr lang="en-US" sz="700" dirty="0">
+                <a:solidFill>
+                  <a:srgbClr val="7D8798"/>
+                </a:solidFill>
+                <a:latin typeface="Arial" pitchFamily="34" charset="0"/>
+                <a:ea typeface="Arial" pitchFamily="34" charset="-122"/>
+                <a:cs typeface="Arial" pitchFamily="34" charset="-120"/>
               </a:rPr>
-              <a:t>02</a:t>
-            </a:r>
-            <a:endParaRPr lang="en-US" sz="2400" dirty="0"/>
-          </a:p>
-        </p:txBody>
-      </p:sp>
-      <p:sp>
-        <p:nvSpPr>
-          <p:cNvPr id="24" name="Text 9">
-            <a:extLst>
-              <a:ext uri="{FF2B5EF4-FFF2-40B4-BE49-F238E27FC236}">
-                <a16:creationId xmlns:a16="http://schemas.microsoft.com/office/drawing/2014/main" id="{19CF8FE5-7439-117D-008F-F76D059AE7B8}"/>
-              </a:ext>
-            </a:extLst>
-          </p:cNvPr>
-          <p:cNvSpPr txBox="1"/>
-          <p:nvPr/>
-        </p:nvSpPr>
-        <p:spPr>
-          <a:xfrm>
-            <a:off x="1221434" y="3077534"/>
-            <a:ext cx="7977318" cy="365760"/>
-          </a:xfrm>
-          <a:prstGeom prst="rect">
-            <a:avLst/>
-          </a:prstGeom>
-          <a:noFill/>
-          <a:ln/>
-        </p:spPr>
-        <p:txBody>
-          <a:bodyPr wrap="square" lIns="0" tIns="0" rIns="0" bIns="0" rtlCol="0" anchor="ctr"/>
-          <a:lstStyle/>
-          <a:p>
-            <a:pPr algn="just"/>
-            <a:r>
-              <a:rPr lang="en-US" sz="2400" b="1" dirty="0"/>
-              <a:t>Testing and validation</a:t>
-            </a:r>
-          </a:p>
-        </p:txBody>
-      </p:sp>
-      <p:sp>
-        <p:nvSpPr>
-          <p:cNvPr id="26" name="Text 10">
-            <a:extLst>
-              <a:ext uri="{FF2B5EF4-FFF2-40B4-BE49-F238E27FC236}">
-                <a16:creationId xmlns:a16="http://schemas.microsoft.com/office/drawing/2014/main" id="{BD6409BA-C1D5-6B9A-EDFA-116DDFE6EFAC}"/>
-              </a:ext>
-            </a:extLst>
-          </p:cNvPr>
-          <p:cNvSpPr txBox="1"/>
-          <p:nvPr/>
-        </p:nvSpPr>
-        <p:spPr>
-          <a:xfrm>
-            <a:off x="1221434" y="3808675"/>
-            <a:ext cx="9820605" cy="640080"/>
-          </a:xfrm>
-          <a:prstGeom prst="rect">
-            <a:avLst/>
-          </a:prstGeom>
-          <a:noFill/>
-          <a:ln/>
-        </p:spPr>
-        <p:txBody>
-          <a:bodyPr wrap="square" lIns="0" tIns="0" rIns="0" bIns="0" rtlCol="0" anchor="ctr"/>
-          <a:lstStyle/>
-          <a:p>
-            <a:r>
-              <a:rPr lang="en-US" sz="2000" dirty="0"/>
-              <a:t>Three tests were executed. The HTTP status and FHIR Patient structure tests passed, while the FHIR-specific Content-Type test failed because application/</a:t>
-            </a:r>
-            <a:r>
-              <a:rPr lang="en-US" sz="2000" dirty="0" err="1"/>
-              <a:t>fhir+json</a:t>
-            </a:r>
-            <a:r>
-              <a:rPr lang="en-US" sz="2000" dirty="0"/>
-              <a:t> was not configured. The failure was documented for correction and regression testing.</a:t>
-            </a:r>
-          </a:p>
-        </p:txBody>
-      </p:sp>
-      <p:sp>
-        <p:nvSpPr>
-          <p:cNvPr id="28" name="TextBox 27">
-            <a:extLst>
-              <a:ext uri="{FF2B5EF4-FFF2-40B4-BE49-F238E27FC236}">
-                <a16:creationId xmlns:a16="http://schemas.microsoft.com/office/drawing/2014/main" id="{334D7A93-5E34-14CD-BF55-EDDB1ABFC188}"/>
-              </a:ext>
-            </a:extLst>
-          </p:cNvPr>
-          <p:cNvSpPr txBox="1"/>
-          <p:nvPr/>
-        </p:nvSpPr>
-        <p:spPr>
-          <a:xfrm>
-            <a:off x="359055" y="4907195"/>
-            <a:ext cx="11255045" cy="1722900"/>
-          </a:xfrm>
-          <a:prstGeom prst="rect">
-            <a:avLst/>
-          </a:prstGeom>
-          <a:solidFill>
-            <a:srgbClr val="F4F7FD"/>
-          </a:solidFill>
-        </p:spPr>
-        <p:txBody>
-          <a:bodyPr wrap="square" rtlCol="0">
-            <a:spAutoFit/>
-          </a:bodyPr>
-          <a:lstStyle/>
-          <a:p>
-            <a:endParaRPr lang="en-AU" dirty="0"/>
-          </a:p>
-        </p:txBody>
-      </p:sp>
-      <p:sp>
-        <p:nvSpPr>
-          <p:cNvPr id="30" name="Text 12">
-            <a:extLst>
-              <a:ext uri="{FF2B5EF4-FFF2-40B4-BE49-F238E27FC236}">
-                <a16:creationId xmlns:a16="http://schemas.microsoft.com/office/drawing/2014/main" id="{E504D35B-4960-D920-25C5-0818CFA831F6}"/>
-              </a:ext>
-            </a:extLst>
-          </p:cNvPr>
-          <p:cNvSpPr txBox="1"/>
-          <p:nvPr/>
-        </p:nvSpPr>
-        <p:spPr>
-          <a:xfrm>
-            <a:off x="565133" y="5124223"/>
-            <a:ext cx="822960" cy="1170432"/>
-          </a:xfrm>
-          <a:prstGeom prst="rect">
-            <a:avLst/>
-          </a:prstGeom>
-          <a:noFill/>
-          <a:ln/>
-        </p:spPr>
-        <p:txBody>
-          <a:bodyPr wrap="square" lIns="0" tIns="0" rIns="0" bIns="0" rtlCol="0" anchor="t"/>
-          <a:lstStyle/>
-          <a:p>
-            <a:pPr marL="0" indent="0" algn="just">
-              <a:buNone/>
-            </a:pPr>
-            <a:r>
-              <a:rPr lang="en-US" sz="2400" b="1" dirty="0">
-                <a:latin typeface="Cambria" pitchFamily="34" charset="0"/>
-                <a:ea typeface="Cambria" pitchFamily="34" charset="-122"/>
-                <a:cs typeface="Cambria" pitchFamily="34" charset="-120"/>
-              </a:rPr>
-              <a:t>03</a:t>
-            </a:r>
-            <a:endParaRPr lang="en-US" sz="2400" dirty="0"/>
-          </a:p>
-        </p:txBody>
-      </p:sp>
-      <p:sp>
-        <p:nvSpPr>
-          <p:cNvPr id="32" name="Text 13">
-            <a:extLst>
-              <a:ext uri="{FF2B5EF4-FFF2-40B4-BE49-F238E27FC236}">
-                <a16:creationId xmlns:a16="http://schemas.microsoft.com/office/drawing/2014/main" id="{C0C469EC-634E-B26C-43C0-CC74677170EA}"/>
-              </a:ext>
-            </a:extLst>
-          </p:cNvPr>
-          <p:cNvSpPr txBox="1"/>
-          <p:nvPr/>
-        </p:nvSpPr>
-        <p:spPr>
-          <a:xfrm>
-            <a:off x="1289099" y="5154030"/>
-            <a:ext cx="6126480" cy="365760"/>
-          </a:xfrm>
-          <a:prstGeom prst="rect">
-            <a:avLst/>
-          </a:prstGeom>
-          <a:noFill/>
-          <a:ln/>
-        </p:spPr>
-        <p:txBody>
-          <a:bodyPr wrap="square" lIns="0" tIns="0" rIns="0" bIns="0" rtlCol="0" anchor="ctr"/>
-          <a:lstStyle/>
-          <a:p>
-            <a:pPr algn="just"/>
-            <a:r>
-              <a:rPr lang="en-US" sz="2400" b="1" dirty="0"/>
-              <a:t>Security, privacy and governance</a:t>
-            </a:r>
-          </a:p>
-        </p:txBody>
-      </p:sp>
-      <p:sp>
-        <p:nvSpPr>
-          <p:cNvPr id="34" name="Text 14">
-            <a:extLst>
-              <a:ext uri="{FF2B5EF4-FFF2-40B4-BE49-F238E27FC236}">
-                <a16:creationId xmlns:a16="http://schemas.microsoft.com/office/drawing/2014/main" id="{9357F957-6328-103D-7016-08BF0D20641D}"/>
-              </a:ext>
-            </a:extLst>
-          </p:cNvPr>
-          <p:cNvSpPr txBox="1"/>
-          <p:nvPr/>
-        </p:nvSpPr>
-        <p:spPr>
-          <a:xfrm>
-            <a:off x="1289099" y="5767681"/>
-            <a:ext cx="9947048" cy="640080"/>
-          </a:xfrm>
-          <a:prstGeom prst="rect">
-            <a:avLst/>
-          </a:prstGeom>
-          <a:noFill/>
-          <a:ln/>
-        </p:spPr>
-        <p:txBody>
-          <a:bodyPr wrap="square" lIns="0" tIns="0" rIns="0" bIns="0" rtlCol="0" anchor="ctr"/>
-          <a:lstStyle/>
-          <a:p>
-            <a:pPr algn="just"/>
-            <a:r>
-              <a:rPr lang="en-US" sz="2000" dirty="0"/>
-              <a:t>The PoC uses synthetic patient data only. NIST CSF 2.0 was used to map data security, access control and monitoring controls, while authentication and stronger security controls remain planned.</a:t>
-            </a:r>
+              <a:t>24</a:t>
+            </a:r>
+            <a:endParaRPr lang="en-US" sz="700" dirty="0"/>
           </a:p>
         </p:txBody>
       </p:sp>
     </p:spTree>
-    <p:extLst>
-      <p:ext uri="{BB962C8B-B14F-4D97-AF65-F5344CB8AC3E}">
-        <p14:creationId xmlns:p14="http://schemas.microsoft.com/office/powerpoint/2010/main" val="2183847905"/>
-      </p:ext>
-    </p:extLst>
   </p:cSld>
   <p:clrMapOvr>
     <a:masterClrMapping/>
@@ -21946,6 +22520,541 @@
 </file>
 
 <file path=ppt/slides/slide20.xml><?xml version="1.0" encoding="utf-8"?>
+<p:sld xmlns:a="http://schemas.openxmlformats.org/drawingml/2006/main" xmlns:r="http://schemas.openxmlformats.org/officeDocument/2006/relationships" xmlns:p="http://schemas.openxmlformats.org/presentationml/2006/main">
+  <p:cSld>
+    <p:spTree>
+      <p:nvGrpSpPr>
+        <p:cNvPr id="1" name="">
+          <a:extLst>
+            <a:ext uri="{FF2B5EF4-FFF2-40B4-BE49-F238E27FC236}">
+              <a16:creationId xmlns:a16="http://schemas.microsoft.com/office/drawing/2014/main" id="{3E278A65-6CF0-1A9E-D226-632F4987A7A1}"/>
+            </a:ext>
+          </a:extLst>
+        </p:cNvPr>
+        <p:cNvGrpSpPr/>
+        <p:nvPr/>
+      </p:nvGrpSpPr>
+      <p:grpSpPr>
+        <a:xfrm>
+          <a:off x="0" y="0"/>
+          <a:ext cx="0" cy="0"/>
+          <a:chOff x="0" y="0"/>
+          <a:chExt cx="0" cy="0"/>
+        </a:xfrm>
+      </p:grpSpPr>
+      <p:sp>
+        <p:nvSpPr>
+          <p:cNvPr id="2" name="Title 1">
+            <a:extLst>
+              <a:ext uri="{FF2B5EF4-FFF2-40B4-BE49-F238E27FC236}">
+                <a16:creationId xmlns:a16="http://schemas.microsoft.com/office/drawing/2014/main" id="{DC398663-CAC8-9555-EB4E-7E738BD79D9F}"/>
+              </a:ext>
+            </a:extLst>
+          </p:cNvPr>
+          <p:cNvSpPr>
+            <a:spLocks noGrp="1"/>
+          </p:cNvSpPr>
+          <p:nvPr>
+            <p:ph type="title"/>
+          </p:nvPr>
+        </p:nvSpPr>
+        <p:spPr>
+          <a:xfrm>
+            <a:off x="359055" y="39083"/>
+            <a:ext cx="10515600" cy="1129992"/>
+          </a:xfrm>
+        </p:spPr>
+        <p:txBody>
+          <a:bodyPr>
+            <a:normAutofit/>
+          </a:bodyPr>
+          <a:lstStyle/>
+          <a:p>
+            <a:pPr algn="just"/>
+            <a:r>
+              <a:rPr lang="en-US" sz="3500" b="1" dirty="0">
+                <a:solidFill>
+                  <a:schemeClr val="tx2"/>
+                </a:solidFill>
+                <a:latin typeface="Calibri" panose="020F0502020204030204" pitchFamily="34" charset="0"/>
+                <a:ea typeface="Calibri" panose="020F0502020204030204" pitchFamily="34" charset="0"/>
+                <a:cs typeface="Calibri" panose="020F0502020204030204" pitchFamily="34" charset="0"/>
+              </a:rPr>
+              <a:t>Proof of Concept, Testing and Cybersecurity Evaluation</a:t>
+            </a:r>
+          </a:p>
+        </p:txBody>
+      </p:sp>
+      <p:sp>
+        <p:nvSpPr>
+          <p:cNvPr id="6" name="TextBox 5">
+            <a:extLst>
+              <a:ext uri="{FF2B5EF4-FFF2-40B4-BE49-F238E27FC236}">
+                <a16:creationId xmlns:a16="http://schemas.microsoft.com/office/drawing/2014/main" id="{F2785A4F-40E6-A1BA-F3F8-DC1FD5027CF6}"/>
+              </a:ext>
+            </a:extLst>
+          </p:cNvPr>
+          <p:cNvSpPr txBox="1"/>
+          <p:nvPr/>
+        </p:nvSpPr>
+        <p:spPr>
+          <a:xfrm>
+            <a:off x="350520" y="1089355"/>
+            <a:ext cx="11255045" cy="1785519"/>
+          </a:xfrm>
+          <a:prstGeom prst="rect">
+            <a:avLst/>
+          </a:prstGeom>
+          <a:solidFill>
+            <a:srgbClr val="F4F7FD"/>
+          </a:solidFill>
+        </p:spPr>
+        <p:txBody>
+          <a:bodyPr wrap="square" rtlCol="0">
+            <a:spAutoFit/>
+          </a:bodyPr>
+          <a:lstStyle/>
+          <a:p>
+            <a:endParaRPr lang="en-AU" dirty="0"/>
+          </a:p>
+        </p:txBody>
+      </p:sp>
+      <p:sp>
+        <p:nvSpPr>
+          <p:cNvPr id="10" name="Text 4">
+            <a:extLst>
+              <a:ext uri="{FF2B5EF4-FFF2-40B4-BE49-F238E27FC236}">
+                <a16:creationId xmlns:a16="http://schemas.microsoft.com/office/drawing/2014/main" id="{7D8DE7F3-444E-D654-CF78-C5AE123A96C4}"/>
+              </a:ext>
+            </a:extLst>
+          </p:cNvPr>
+          <p:cNvSpPr txBox="1"/>
+          <p:nvPr/>
+        </p:nvSpPr>
+        <p:spPr>
+          <a:xfrm>
+            <a:off x="586435" y="1303626"/>
+            <a:ext cx="822960" cy="1170432"/>
+          </a:xfrm>
+          <a:prstGeom prst="rect">
+            <a:avLst/>
+          </a:prstGeom>
+          <a:noFill/>
+          <a:ln/>
+        </p:spPr>
+        <p:txBody>
+          <a:bodyPr wrap="square" lIns="0" tIns="0" rIns="0" bIns="0" rtlCol="0" anchor="t"/>
+          <a:lstStyle/>
+          <a:p>
+            <a:pPr marL="0" indent="0" algn="just">
+              <a:buNone/>
+            </a:pPr>
+            <a:r>
+              <a:rPr lang="en-US" sz="2400" b="1" dirty="0">
+                <a:latin typeface="Cambria" pitchFamily="34" charset="0"/>
+                <a:ea typeface="Cambria" pitchFamily="34" charset="-122"/>
+                <a:cs typeface="Cambria" pitchFamily="34" charset="-120"/>
+              </a:rPr>
+              <a:t>01</a:t>
+            </a:r>
+            <a:endParaRPr lang="en-US" sz="2400" dirty="0"/>
+          </a:p>
+        </p:txBody>
+      </p:sp>
+      <p:sp>
+        <p:nvSpPr>
+          <p:cNvPr id="16" name="Text 5">
+            <a:extLst>
+              <a:ext uri="{FF2B5EF4-FFF2-40B4-BE49-F238E27FC236}">
+                <a16:creationId xmlns:a16="http://schemas.microsoft.com/office/drawing/2014/main" id="{E519C6E1-0695-0AD2-CB76-A084E34A8410}"/>
+              </a:ext>
+            </a:extLst>
+          </p:cNvPr>
+          <p:cNvSpPr txBox="1"/>
+          <p:nvPr/>
+        </p:nvSpPr>
+        <p:spPr>
+          <a:xfrm>
+            <a:off x="1221435" y="1282290"/>
+            <a:ext cx="6126480" cy="365760"/>
+          </a:xfrm>
+          <a:prstGeom prst="rect">
+            <a:avLst/>
+          </a:prstGeom>
+          <a:noFill/>
+          <a:ln/>
+        </p:spPr>
+        <p:txBody>
+          <a:bodyPr wrap="square" lIns="0" tIns="0" rIns="0" bIns="0" rtlCol="0" anchor="ctr"/>
+          <a:lstStyle/>
+          <a:p>
+            <a:pPr algn="just"/>
+            <a:r>
+              <a:rPr lang="en-US" sz="2400" b="1" dirty="0">
+                <a:latin typeface="Calibri" panose="020F0502020204030204" pitchFamily="34" charset="0"/>
+                <a:ea typeface="Calibri" panose="020F0502020204030204" pitchFamily="34" charset="0"/>
+                <a:cs typeface="Calibri" panose="020F0502020204030204" pitchFamily="34" charset="0"/>
+              </a:rPr>
+              <a:t>Working Proof of Concept</a:t>
+            </a:r>
+          </a:p>
+        </p:txBody>
+      </p:sp>
+      <p:sp>
+        <p:nvSpPr>
+          <p:cNvPr id="18" name="Text 6">
+            <a:extLst>
+              <a:ext uri="{FF2B5EF4-FFF2-40B4-BE49-F238E27FC236}">
+                <a16:creationId xmlns:a16="http://schemas.microsoft.com/office/drawing/2014/main" id="{0D55470B-E2B6-6833-56B6-194FF1AD5C5F}"/>
+              </a:ext>
+            </a:extLst>
+          </p:cNvPr>
+          <p:cNvSpPr txBox="1"/>
+          <p:nvPr/>
+        </p:nvSpPr>
+        <p:spPr>
+          <a:xfrm>
+            <a:off x="1221434" y="1863825"/>
+            <a:ext cx="9736735" cy="640080"/>
+          </a:xfrm>
+          <a:prstGeom prst="rect">
+            <a:avLst/>
+          </a:prstGeom>
+          <a:noFill/>
+          <a:ln/>
+        </p:spPr>
+        <p:txBody>
+          <a:bodyPr wrap="square" lIns="0" tIns="0" rIns="0" bIns="0" rtlCol="0" anchor="ctr"/>
+          <a:lstStyle/>
+          <a:p>
+            <a:r>
+              <a:rPr lang="en-US" sz="2000" dirty="0"/>
+              <a:t>I configured a synthetic FHIR R4 Patient mock endpoint in Postman that responds to GET /</a:t>
+            </a:r>
+            <a:r>
+              <a:rPr lang="en-US" sz="2000" dirty="0" err="1"/>
+              <a:t>fhir</a:t>
+            </a:r>
+            <a:r>
+              <a:rPr lang="en-US" sz="2000" dirty="0"/>
+              <a:t>/R4/Patient/SYNTH-001 with a synthetic Patient resource and HTTP 200 OK.</a:t>
+            </a:r>
+          </a:p>
+        </p:txBody>
+      </p:sp>
+      <p:sp>
+        <p:nvSpPr>
+          <p:cNvPr id="20" name="TextBox 19">
+            <a:extLst>
+              <a:ext uri="{FF2B5EF4-FFF2-40B4-BE49-F238E27FC236}">
+                <a16:creationId xmlns:a16="http://schemas.microsoft.com/office/drawing/2014/main" id="{97B7CCC5-38B6-5581-91AF-4DF4BE5242AB}"/>
+              </a:ext>
+            </a:extLst>
+          </p:cNvPr>
+          <p:cNvSpPr txBox="1"/>
+          <p:nvPr/>
+        </p:nvSpPr>
+        <p:spPr>
+          <a:xfrm>
+            <a:off x="347676" y="2988090"/>
+            <a:ext cx="11255045" cy="1722900"/>
+          </a:xfrm>
+          <a:prstGeom prst="rect">
+            <a:avLst/>
+          </a:prstGeom>
+          <a:solidFill>
+            <a:srgbClr val="F4F7FD"/>
+          </a:solidFill>
+        </p:spPr>
+        <p:txBody>
+          <a:bodyPr wrap="square" rtlCol="0">
+            <a:spAutoFit/>
+          </a:bodyPr>
+          <a:lstStyle/>
+          <a:p>
+            <a:endParaRPr lang="en-AU" dirty="0"/>
+          </a:p>
+        </p:txBody>
+      </p:sp>
+      <p:sp>
+        <p:nvSpPr>
+          <p:cNvPr id="22" name="Text 8">
+            <a:extLst>
+              <a:ext uri="{FF2B5EF4-FFF2-40B4-BE49-F238E27FC236}">
+                <a16:creationId xmlns:a16="http://schemas.microsoft.com/office/drawing/2014/main" id="{0B13388C-6D0C-309F-D29C-B815BD090CA6}"/>
+              </a:ext>
+            </a:extLst>
+          </p:cNvPr>
+          <p:cNvSpPr txBox="1"/>
+          <p:nvPr/>
+        </p:nvSpPr>
+        <p:spPr>
+          <a:xfrm>
+            <a:off x="542339" y="3133206"/>
+            <a:ext cx="1213993" cy="1170432"/>
+          </a:xfrm>
+          <a:prstGeom prst="rect">
+            <a:avLst/>
+          </a:prstGeom>
+          <a:noFill/>
+          <a:ln/>
+        </p:spPr>
+        <p:txBody>
+          <a:bodyPr wrap="square" lIns="0" tIns="0" rIns="0" bIns="0" rtlCol="0" anchor="t"/>
+          <a:lstStyle/>
+          <a:p>
+            <a:pPr marL="0" indent="0" algn="just">
+              <a:buNone/>
+            </a:pPr>
+            <a:r>
+              <a:rPr lang="en-US" sz="2400" b="1" dirty="0">
+                <a:latin typeface="Cambria" pitchFamily="34" charset="0"/>
+                <a:ea typeface="Cambria" pitchFamily="34" charset="-122"/>
+                <a:cs typeface="Cambria" pitchFamily="34" charset="-120"/>
+              </a:rPr>
+              <a:t>02</a:t>
+            </a:r>
+            <a:endParaRPr lang="en-US" sz="2400" dirty="0"/>
+          </a:p>
+        </p:txBody>
+      </p:sp>
+      <p:sp>
+        <p:nvSpPr>
+          <p:cNvPr id="24" name="Text 9">
+            <a:extLst>
+              <a:ext uri="{FF2B5EF4-FFF2-40B4-BE49-F238E27FC236}">
+                <a16:creationId xmlns:a16="http://schemas.microsoft.com/office/drawing/2014/main" id="{19CF8FE5-7439-117D-008F-F76D059AE7B8}"/>
+              </a:ext>
+            </a:extLst>
+          </p:cNvPr>
+          <p:cNvSpPr txBox="1"/>
+          <p:nvPr/>
+        </p:nvSpPr>
+        <p:spPr>
+          <a:xfrm>
+            <a:off x="1221434" y="3077534"/>
+            <a:ext cx="7977318" cy="365760"/>
+          </a:xfrm>
+          <a:prstGeom prst="rect">
+            <a:avLst/>
+          </a:prstGeom>
+          <a:noFill/>
+          <a:ln/>
+        </p:spPr>
+        <p:txBody>
+          <a:bodyPr wrap="square" lIns="0" tIns="0" rIns="0" bIns="0" rtlCol="0" anchor="ctr"/>
+          <a:lstStyle/>
+          <a:p>
+            <a:pPr algn="just"/>
+            <a:r>
+              <a:rPr lang="en-US" sz="2400" b="1" dirty="0"/>
+              <a:t>Testing and validation</a:t>
+            </a:r>
+          </a:p>
+        </p:txBody>
+      </p:sp>
+      <p:sp>
+        <p:nvSpPr>
+          <p:cNvPr id="26" name="Text 10">
+            <a:extLst>
+              <a:ext uri="{FF2B5EF4-FFF2-40B4-BE49-F238E27FC236}">
+                <a16:creationId xmlns:a16="http://schemas.microsoft.com/office/drawing/2014/main" id="{BD6409BA-C1D5-6B9A-EDFA-116DDFE6EFAC}"/>
+              </a:ext>
+            </a:extLst>
+          </p:cNvPr>
+          <p:cNvSpPr txBox="1"/>
+          <p:nvPr/>
+        </p:nvSpPr>
+        <p:spPr>
+          <a:xfrm>
+            <a:off x="1221434" y="3808675"/>
+            <a:ext cx="9820605" cy="640080"/>
+          </a:xfrm>
+          <a:prstGeom prst="rect">
+            <a:avLst/>
+          </a:prstGeom>
+          <a:noFill/>
+          <a:ln/>
+        </p:spPr>
+        <p:txBody>
+          <a:bodyPr wrap="square" lIns="0" tIns="0" rIns="0" bIns="0" rtlCol="0" anchor="ctr"/>
+          <a:lstStyle/>
+          <a:p>
+            <a:r>
+              <a:rPr lang="en-US" sz="2000" dirty="0"/>
+              <a:t>Three tests were executed. The HTTP status and FHIR Patient structure tests passed, while the FHIR-specific Content-Type test failed because application/</a:t>
+            </a:r>
+            <a:r>
+              <a:rPr lang="en-US" sz="2000" dirty="0" err="1"/>
+              <a:t>fhir+json</a:t>
+            </a:r>
+            <a:r>
+              <a:rPr lang="en-US" sz="2000" dirty="0"/>
+              <a:t> was not configured. The failure was documented for correction and regression testing.</a:t>
+            </a:r>
+          </a:p>
+        </p:txBody>
+      </p:sp>
+      <p:sp>
+        <p:nvSpPr>
+          <p:cNvPr id="28" name="TextBox 27">
+            <a:extLst>
+              <a:ext uri="{FF2B5EF4-FFF2-40B4-BE49-F238E27FC236}">
+                <a16:creationId xmlns:a16="http://schemas.microsoft.com/office/drawing/2014/main" id="{334D7A93-5E34-14CD-BF55-EDDB1ABFC188}"/>
+              </a:ext>
+            </a:extLst>
+          </p:cNvPr>
+          <p:cNvSpPr txBox="1"/>
+          <p:nvPr/>
+        </p:nvSpPr>
+        <p:spPr>
+          <a:xfrm>
+            <a:off x="359055" y="4907195"/>
+            <a:ext cx="11255045" cy="1722900"/>
+          </a:xfrm>
+          <a:prstGeom prst="rect">
+            <a:avLst/>
+          </a:prstGeom>
+          <a:solidFill>
+            <a:srgbClr val="F4F7FD"/>
+          </a:solidFill>
+        </p:spPr>
+        <p:txBody>
+          <a:bodyPr wrap="square" rtlCol="0">
+            <a:spAutoFit/>
+          </a:bodyPr>
+          <a:lstStyle/>
+          <a:p>
+            <a:endParaRPr lang="en-AU" dirty="0"/>
+          </a:p>
+        </p:txBody>
+      </p:sp>
+      <p:sp>
+        <p:nvSpPr>
+          <p:cNvPr id="30" name="Text 12">
+            <a:extLst>
+              <a:ext uri="{FF2B5EF4-FFF2-40B4-BE49-F238E27FC236}">
+                <a16:creationId xmlns:a16="http://schemas.microsoft.com/office/drawing/2014/main" id="{E504D35B-4960-D920-25C5-0818CFA831F6}"/>
+              </a:ext>
+            </a:extLst>
+          </p:cNvPr>
+          <p:cNvSpPr txBox="1"/>
+          <p:nvPr/>
+        </p:nvSpPr>
+        <p:spPr>
+          <a:xfrm>
+            <a:off x="565133" y="5124223"/>
+            <a:ext cx="822960" cy="1170432"/>
+          </a:xfrm>
+          <a:prstGeom prst="rect">
+            <a:avLst/>
+          </a:prstGeom>
+          <a:noFill/>
+          <a:ln/>
+        </p:spPr>
+        <p:txBody>
+          <a:bodyPr wrap="square" lIns="0" tIns="0" rIns="0" bIns="0" rtlCol="0" anchor="t"/>
+          <a:lstStyle/>
+          <a:p>
+            <a:pPr marL="0" indent="0" algn="just">
+              <a:buNone/>
+            </a:pPr>
+            <a:r>
+              <a:rPr lang="en-US" sz="2400" b="1" dirty="0">
+                <a:latin typeface="Cambria" pitchFamily="34" charset="0"/>
+                <a:ea typeface="Cambria" pitchFamily="34" charset="-122"/>
+                <a:cs typeface="Cambria" pitchFamily="34" charset="-120"/>
+              </a:rPr>
+              <a:t>03</a:t>
+            </a:r>
+            <a:endParaRPr lang="en-US" sz="2400" dirty="0"/>
+          </a:p>
+        </p:txBody>
+      </p:sp>
+      <p:sp>
+        <p:nvSpPr>
+          <p:cNvPr id="32" name="Text 13">
+            <a:extLst>
+              <a:ext uri="{FF2B5EF4-FFF2-40B4-BE49-F238E27FC236}">
+                <a16:creationId xmlns:a16="http://schemas.microsoft.com/office/drawing/2014/main" id="{C0C469EC-634E-B26C-43C0-CC74677170EA}"/>
+              </a:ext>
+            </a:extLst>
+          </p:cNvPr>
+          <p:cNvSpPr txBox="1"/>
+          <p:nvPr/>
+        </p:nvSpPr>
+        <p:spPr>
+          <a:xfrm>
+            <a:off x="1289099" y="5154030"/>
+            <a:ext cx="6126480" cy="365760"/>
+          </a:xfrm>
+          <a:prstGeom prst="rect">
+            <a:avLst/>
+          </a:prstGeom>
+          <a:noFill/>
+          <a:ln/>
+        </p:spPr>
+        <p:txBody>
+          <a:bodyPr wrap="square" lIns="0" tIns="0" rIns="0" bIns="0" rtlCol="0" anchor="ctr"/>
+          <a:lstStyle/>
+          <a:p>
+            <a:pPr algn="just"/>
+            <a:r>
+              <a:rPr lang="en-US" sz="2400" b="1" dirty="0"/>
+              <a:t>Security, privacy and governance</a:t>
+            </a:r>
+          </a:p>
+        </p:txBody>
+      </p:sp>
+      <p:sp>
+        <p:nvSpPr>
+          <p:cNvPr id="34" name="Text 14">
+            <a:extLst>
+              <a:ext uri="{FF2B5EF4-FFF2-40B4-BE49-F238E27FC236}">
+                <a16:creationId xmlns:a16="http://schemas.microsoft.com/office/drawing/2014/main" id="{9357F957-6328-103D-7016-08BF0D20641D}"/>
+              </a:ext>
+            </a:extLst>
+          </p:cNvPr>
+          <p:cNvSpPr txBox="1"/>
+          <p:nvPr/>
+        </p:nvSpPr>
+        <p:spPr>
+          <a:xfrm>
+            <a:off x="1289099" y="5767681"/>
+            <a:ext cx="9947048" cy="640080"/>
+          </a:xfrm>
+          <a:prstGeom prst="rect">
+            <a:avLst/>
+          </a:prstGeom>
+          <a:noFill/>
+          <a:ln/>
+        </p:spPr>
+        <p:txBody>
+          <a:bodyPr wrap="square" lIns="0" tIns="0" rIns="0" bIns="0" rtlCol="0" anchor="ctr"/>
+          <a:lstStyle/>
+          <a:p>
+            <a:pPr algn="just"/>
+            <a:r>
+              <a:rPr lang="en-US" sz="2000" dirty="0"/>
+              <a:t>The PoC uses synthetic patient data only. NIST CSF 2.0 was used to map data security, access control and monitoring controls, while authentication and stronger security controls remain planned.</a:t>
+            </a:r>
+          </a:p>
+        </p:txBody>
+      </p:sp>
+    </p:spTree>
+    <p:extLst>
+      <p:ext uri="{BB962C8B-B14F-4D97-AF65-F5344CB8AC3E}">
+        <p14:creationId xmlns:p14="http://schemas.microsoft.com/office/powerpoint/2010/main" val="2183847905"/>
+      </p:ext>
+    </p:extLst>
+  </p:cSld>
+  <p:clrMapOvr>
+    <a:masterClrMapping/>
+  </p:clrMapOvr>
+</p:sld>
+</file>
+
+<file path=ppt/slides/slide21.xml><?xml version="1.0" encoding="utf-8"?>
 <p:sld xmlns:a="http://schemas.openxmlformats.org/drawingml/2006/main" xmlns:r="http://schemas.openxmlformats.org/officeDocument/2006/relationships" xmlns:p="http://schemas.openxmlformats.org/presentationml/2006/main">
   <p:cSld>
     <p:spTree>
@@ -22829,7 +23938,7 @@
 </p:sld>
 </file>
 
-<file path=ppt/slides/slide21.xml><?xml version="1.0" encoding="utf-8"?>
+<file path=ppt/slides/slide22.xml><?xml version="1.0" encoding="utf-8"?>
 <p:sld xmlns:a="http://schemas.openxmlformats.org/drawingml/2006/main" xmlns:r="http://schemas.openxmlformats.org/officeDocument/2006/relationships" xmlns:p="http://schemas.openxmlformats.org/presentationml/2006/main">
   <p:cSld>
     <p:spTree>
@@ -22894,7 +24003,1080 @@
 </p:sld>
 </file>
 
-<file path=ppt/slides/slide22.xml><?xml version="1.0" encoding="utf-8"?>
+<file path=ppt/slides/slide23.xml><?xml version="1.0" encoding="utf-8"?>
+<p:sld xmlns:a="http://schemas.openxmlformats.org/drawingml/2006/main" xmlns:r="http://schemas.openxmlformats.org/officeDocument/2006/relationships" xmlns:p="http://schemas.openxmlformats.org/presentationml/2006/main">
+  <p:cSld>
+    <p:spTree>
+      <p:nvGrpSpPr>
+        <p:cNvPr id="1" name=""/>
+        <p:cNvGrpSpPr/>
+        <p:nvPr/>
+      </p:nvGrpSpPr>
+      <p:grpSpPr>
+        <a:xfrm>
+          <a:off x="0" y="0"/>
+          <a:ext cx="0" cy="0"/>
+          <a:chOff x="0" y="0"/>
+          <a:chExt cx="0" cy="0"/>
+        </a:xfrm>
+      </p:grpSpPr>
+      <p:sp>
+        <p:nvSpPr>
+          <p:cNvPr id="2" name="Text 0"/>
+          <p:cNvSpPr/>
+          <p:nvPr/>
+        </p:nvSpPr>
+        <p:spPr>
+          <a:xfrm>
+            <a:off x="1962912" y="402336"/>
+            <a:ext cx="8138160" cy="384048"/>
+          </a:xfrm>
+          <a:prstGeom prst="rect">
+            <a:avLst/>
+          </a:prstGeom>
+          <a:noFill/>
+          <a:ln/>
+        </p:spPr>
+        <p:txBody>
+          <a:bodyPr wrap="square" lIns="0" tIns="0" rIns="0" bIns="0" rtlCol="0" anchor="ctr"/>
+          <a:lstStyle/>
+          <a:p>
+            <a:r>
+              <a:rPr lang="en-US" sz="2400" b="1" dirty="0">
+                <a:solidFill>
+                  <a:srgbClr val="122033"/>
+                </a:solidFill>
+                <a:latin typeface="Arial" pitchFamily="34" charset="0"/>
+                <a:ea typeface="Arial" pitchFamily="34" charset="-122"/>
+                <a:cs typeface="Arial" pitchFamily="34" charset="-120"/>
+              </a:rPr>
+              <a:t>Stage 2 Priorities &amp; Recommendations</a:t>
+            </a:r>
+            <a:endParaRPr lang="en-US" sz="2400" dirty="0"/>
+          </a:p>
+        </p:txBody>
+      </p:sp>
+      <p:sp>
+        <p:nvSpPr>
+          <p:cNvPr id="3" name="Text 1"/>
+          <p:cNvSpPr/>
+          <p:nvPr/>
+        </p:nvSpPr>
+        <p:spPr>
+          <a:xfrm>
+            <a:off x="1981200" y="859536"/>
+            <a:ext cx="7955280" cy="256032"/>
+          </a:xfrm>
+          <a:prstGeom prst="rect">
+            <a:avLst/>
+          </a:prstGeom>
+          <a:noFill/>
+          <a:ln/>
+        </p:spPr>
+        <p:txBody>
+          <a:bodyPr wrap="square" lIns="0" tIns="0" rIns="0" bIns="0" rtlCol="0" anchor="ctr"/>
+          <a:lstStyle/>
+          <a:p>
+            <a:r>
+              <a:rPr lang="en-US" sz="1200" dirty="0">
+                <a:solidFill>
+                  <a:srgbClr val="5B667A"/>
+                </a:solidFill>
+                <a:latin typeface="Arial" pitchFamily="34" charset="0"/>
+                <a:ea typeface="Arial" pitchFamily="34" charset="-122"/>
+                <a:cs typeface="Arial" pitchFamily="34" charset="-120"/>
+              </a:rPr>
+              <a:t>What must be completed before the test harness is treated as production-adjacent</a:t>
+            </a:r>
+            <a:endParaRPr lang="en-US" sz="1200" dirty="0"/>
+          </a:p>
+        </p:txBody>
+      </p:sp>
+      <p:sp>
+        <p:nvSpPr>
+          <p:cNvPr id="4" name="Shape 2"/>
+          <p:cNvSpPr/>
+          <p:nvPr/>
+        </p:nvSpPr>
+        <p:spPr>
+          <a:xfrm>
+            <a:off x="1962912" y="1234440"/>
+            <a:ext cx="8275320" cy="54864"/>
+          </a:xfrm>
+          <a:prstGeom prst="rect">
+            <a:avLst/>
+          </a:prstGeom>
+          <a:solidFill>
+            <a:srgbClr val="182354"/>
+          </a:solidFill>
+          <a:ln w="12700">
+            <a:solidFill>
+              <a:srgbClr val="182354"/>
+            </a:solidFill>
+            <a:prstDash val="solid"/>
+          </a:ln>
+        </p:spPr>
+        <p:txBody>
+          <a:bodyPr/>
+          <a:lstStyle/>
+          <a:p>
+            <a:endParaRPr lang="en-US"/>
+          </a:p>
+        </p:txBody>
+      </p:sp>
+      <p:sp>
+        <p:nvSpPr>
+          <p:cNvPr id="5" name="Text 3"/>
+          <p:cNvSpPr/>
+          <p:nvPr/>
+        </p:nvSpPr>
+        <p:spPr>
+          <a:xfrm>
+            <a:off x="2072640" y="1481328"/>
+            <a:ext cx="3200400" cy="256032"/>
+          </a:xfrm>
+          <a:prstGeom prst="rect">
+            <a:avLst/>
+          </a:prstGeom>
+          <a:noFill/>
+          <a:ln/>
+        </p:spPr>
+        <p:txBody>
+          <a:bodyPr wrap="square" lIns="0" tIns="0" rIns="0" bIns="0" rtlCol="0" anchor="ctr"/>
+          <a:lstStyle/>
+          <a:p>
+            <a:r>
+              <a:rPr lang="en-US" sz="1400" b="1" dirty="0">
+                <a:solidFill>
+                  <a:srgbClr val="122033"/>
+                </a:solidFill>
+                <a:latin typeface="Arial" pitchFamily="34" charset="0"/>
+                <a:ea typeface="Arial" pitchFamily="34" charset="-122"/>
+                <a:cs typeface="Arial" pitchFamily="34" charset="-120"/>
+              </a:rPr>
+              <a:t>Immediate priorities</a:t>
+            </a:r>
+            <a:endParaRPr lang="en-US" sz="1400" dirty="0"/>
+          </a:p>
+        </p:txBody>
+      </p:sp>
+      <p:sp>
+        <p:nvSpPr>
+          <p:cNvPr id="6" name="Shape 4"/>
+          <p:cNvSpPr/>
+          <p:nvPr/>
+        </p:nvSpPr>
+        <p:spPr>
+          <a:xfrm>
+            <a:off x="2109216" y="1911096"/>
+            <a:ext cx="310896" cy="310896"/>
+          </a:xfrm>
+          <a:prstGeom prst="ellipse">
+            <a:avLst/>
+          </a:prstGeom>
+          <a:solidFill>
+            <a:srgbClr val="182354"/>
+          </a:solidFill>
+          <a:ln w="12700">
+            <a:solidFill>
+              <a:srgbClr val="182354"/>
+            </a:solidFill>
+            <a:prstDash val="solid"/>
+          </a:ln>
+        </p:spPr>
+        <p:txBody>
+          <a:bodyPr/>
+          <a:lstStyle/>
+          <a:p>
+            <a:endParaRPr lang="en-US" sz="1400"/>
+          </a:p>
+        </p:txBody>
+      </p:sp>
+      <p:sp>
+        <p:nvSpPr>
+          <p:cNvPr id="7" name="Text 5"/>
+          <p:cNvSpPr/>
+          <p:nvPr/>
+        </p:nvSpPr>
+        <p:spPr>
+          <a:xfrm>
+            <a:off x="2122932" y="1997964"/>
+            <a:ext cx="283464" cy="73152"/>
+          </a:xfrm>
+          <a:prstGeom prst="rect">
+            <a:avLst/>
+          </a:prstGeom>
+          <a:noFill/>
+          <a:ln/>
+        </p:spPr>
+        <p:txBody>
+          <a:bodyPr wrap="square" lIns="0" tIns="0" rIns="0" bIns="0" rtlCol="0" anchor="ctr"/>
+          <a:lstStyle/>
+          <a:p>
+            <a:pPr algn="ctr"/>
+            <a:r>
+              <a:rPr lang="en-US" sz="1400" b="1" dirty="0">
+                <a:solidFill>
+                  <a:srgbClr val="FFFFFF"/>
+                </a:solidFill>
+                <a:latin typeface="Arial" pitchFamily="34" charset="0"/>
+                <a:ea typeface="Arial" pitchFamily="34" charset="-122"/>
+                <a:cs typeface="Arial" pitchFamily="34" charset="-120"/>
+              </a:rPr>
+              <a:t>01</a:t>
+            </a:r>
+            <a:endParaRPr lang="en-US" sz="1400" dirty="0"/>
+          </a:p>
+        </p:txBody>
+      </p:sp>
+      <p:sp>
+        <p:nvSpPr>
+          <p:cNvPr id="8" name="Text 6"/>
+          <p:cNvSpPr/>
+          <p:nvPr/>
+        </p:nvSpPr>
+        <p:spPr>
+          <a:xfrm>
+            <a:off x="2529840" y="1901952"/>
+            <a:ext cx="3749040" cy="310896"/>
+          </a:xfrm>
+          <a:prstGeom prst="rect">
+            <a:avLst/>
+          </a:prstGeom>
+          <a:noFill/>
+          <a:ln/>
+        </p:spPr>
+        <p:txBody>
+          <a:bodyPr wrap="square" lIns="0" tIns="0" rIns="0" bIns="0" rtlCol="0" anchor="ctr">
+            <a:noAutofit/>
+          </a:bodyPr>
+          <a:lstStyle/>
+          <a:p>
+            <a:r>
+              <a:rPr lang="en-US" sz="1400" dirty="0">
+                <a:solidFill>
+                  <a:srgbClr val="394255"/>
+                </a:solidFill>
+                <a:latin typeface="Arial" pitchFamily="34" charset="0"/>
+                <a:ea typeface="Arial" pitchFamily="34" charset="-122"/>
+                <a:cs typeface="Arial" pitchFamily="34" charset="-120"/>
+              </a:rPr>
+              <a:t>Correct and retest the failed FHIR Content-Type issue</a:t>
+            </a:r>
+            <a:endParaRPr lang="en-US" sz="1400" dirty="0"/>
+          </a:p>
+        </p:txBody>
+      </p:sp>
+      <p:sp>
+        <p:nvSpPr>
+          <p:cNvPr id="9" name="Shape 7"/>
+          <p:cNvSpPr/>
+          <p:nvPr/>
+        </p:nvSpPr>
+        <p:spPr>
+          <a:xfrm>
+            <a:off x="2109216" y="2478024"/>
+            <a:ext cx="310896" cy="310896"/>
+          </a:xfrm>
+          <a:prstGeom prst="ellipse">
+            <a:avLst/>
+          </a:prstGeom>
+          <a:solidFill>
+            <a:srgbClr val="182354"/>
+          </a:solidFill>
+          <a:ln w="12700">
+            <a:solidFill>
+              <a:srgbClr val="182354"/>
+            </a:solidFill>
+            <a:prstDash val="solid"/>
+          </a:ln>
+        </p:spPr>
+        <p:txBody>
+          <a:bodyPr/>
+          <a:lstStyle/>
+          <a:p>
+            <a:endParaRPr lang="en-US" sz="1400"/>
+          </a:p>
+        </p:txBody>
+      </p:sp>
+      <p:sp>
+        <p:nvSpPr>
+          <p:cNvPr id="10" name="Text 8"/>
+          <p:cNvSpPr/>
+          <p:nvPr/>
+        </p:nvSpPr>
+        <p:spPr>
+          <a:xfrm>
+            <a:off x="2122932" y="2564892"/>
+            <a:ext cx="283464" cy="73152"/>
+          </a:xfrm>
+          <a:prstGeom prst="rect">
+            <a:avLst/>
+          </a:prstGeom>
+          <a:noFill/>
+          <a:ln/>
+        </p:spPr>
+        <p:txBody>
+          <a:bodyPr wrap="square" lIns="0" tIns="0" rIns="0" bIns="0" rtlCol="0" anchor="ctr"/>
+          <a:lstStyle/>
+          <a:p>
+            <a:pPr algn="ctr"/>
+            <a:r>
+              <a:rPr lang="en-US" sz="1400" b="1" dirty="0">
+                <a:solidFill>
+                  <a:srgbClr val="FFFFFF"/>
+                </a:solidFill>
+                <a:latin typeface="Arial" pitchFamily="34" charset="0"/>
+                <a:ea typeface="Arial" pitchFamily="34" charset="-122"/>
+                <a:cs typeface="Arial" pitchFamily="34" charset="-120"/>
+              </a:rPr>
+              <a:t>02</a:t>
+            </a:r>
+            <a:endParaRPr lang="en-US" sz="1400" dirty="0"/>
+          </a:p>
+        </p:txBody>
+      </p:sp>
+      <p:sp>
+        <p:nvSpPr>
+          <p:cNvPr id="11" name="Text 9"/>
+          <p:cNvSpPr/>
+          <p:nvPr/>
+        </p:nvSpPr>
+        <p:spPr>
+          <a:xfrm>
+            <a:off x="2529840" y="2468880"/>
+            <a:ext cx="3749040" cy="310896"/>
+          </a:xfrm>
+          <a:prstGeom prst="rect">
+            <a:avLst/>
+          </a:prstGeom>
+          <a:noFill/>
+          <a:ln/>
+        </p:spPr>
+        <p:txBody>
+          <a:bodyPr wrap="square" lIns="0" tIns="0" rIns="0" bIns="0" rtlCol="0" anchor="ctr">
+            <a:noAutofit/>
+          </a:bodyPr>
+          <a:lstStyle/>
+          <a:p>
+            <a:r>
+              <a:rPr lang="en-US" sz="1400" dirty="0">
+                <a:solidFill>
+                  <a:srgbClr val="394255"/>
+                </a:solidFill>
+                <a:latin typeface="Arial" pitchFamily="34" charset="0"/>
+                <a:ea typeface="Arial" pitchFamily="34" charset="-122"/>
+                <a:cs typeface="Arial" pitchFamily="34" charset="-120"/>
+              </a:rPr>
+              <a:t>Implement authentication, RBAC and tenant isolation</a:t>
+            </a:r>
+            <a:endParaRPr lang="en-US" sz="1400" dirty="0"/>
+          </a:p>
+        </p:txBody>
+      </p:sp>
+      <p:sp>
+        <p:nvSpPr>
+          <p:cNvPr id="12" name="Shape 10"/>
+          <p:cNvSpPr/>
+          <p:nvPr/>
+        </p:nvSpPr>
+        <p:spPr>
+          <a:xfrm>
+            <a:off x="2109216" y="3044952"/>
+            <a:ext cx="310896" cy="310896"/>
+          </a:xfrm>
+          <a:prstGeom prst="ellipse">
+            <a:avLst/>
+          </a:prstGeom>
+          <a:solidFill>
+            <a:srgbClr val="182354"/>
+          </a:solidFill>
+          <a:ln w="12700">
+            <a:solidFill>
+              <a:srgbClr val="182354"/>
+            </a:solidFill>
+            <a:prstDash val="solid"/>
+          </a:ln>
+        </p:spPr>
+        <p:txBody>
+          <a:bodyPr/>
+          <a:lstStyle/>
+          <a:p>
+            <a:endParaRPr lang="en-US" sz="1400"/>
+          </a:p>
+        </p:txBody>
+      </p:sp>
+      <p:sp>
+        <p:nvSpPr>
+          <p:cNvPr id="13" name="Text 11"/>
+          <p:cNvSpPr/>
+          <p:nvPr/>
+        </p:nvSpPr>
+        <p:spPr>
+          <a:xfrm>
+            <a:off x="2122932" y="3131820"/>
+            <a:ext cx="283464" cy="73152"/>
+          </a:xfrm>
+          <a:prstGeom prst="rect">
+            <a:avLst/>
+          </a:prstGeom>
+          <a:noFill/>
+          <a:ln/>
+        </p:spPr>
+        <p:txBody>
+          <a:bodyPr wrap="square" lIns="0" tIns="0" rIns="0" bIns="0" rtlCol="0" anchor="ctr"/>
+          <a:lstStyle/>
+          <a:p>
+            <a:pPr algn="ctr"/>
+            <a:r>
+              <a:rPr lang="en-US" sz="1400" b="1" dirty="0">
+                <a:solidFill>
+                  <a:srgbClr val="FFFFFF"/>
+                </a:solidFill>
+                <a:latin typeface="Arial" pitchFamily="34" charset="0"/>
+                <a:ea typeface="Arial" pitchFamily="34" charset="-122"/>
+                <a:cs typeface="Arial" pitchFamily="34" charset="-120"/>
+              </a:rPr>
+              <a:t>03</a:t>
+            </a:r>
+            <a:endParaRPr lang="en-US" sz="1400" dirty="0"/>
+          </a:p>
+        </p:txBody>
+      </p:sp>
+      <p:sp>
+        <p:nvSpPr>
+          <p:cNvPr id="14" name="Text 12"/>
+          <p:cNvSpPr/>
+          <p:nvPr/>
+        </p:nvSpPr>
+        <p:spPr>
+          <a:xfrm>
+            <a:off x="2529840" y="3035808"/>
+            <a:ext cx="3749040" cy="310896"/>
+          </a:xfrm>
+          <a:prstGeom prst="rect">
+            <a:avLst/>
+          </a:prstGeom>
+          <a:noFill/>
+          <a:ln/>
+        </p:spPr>
+        <p:txBody>
+          <a:bodyPr wrap="square" lIns="0" tIns="0" rIns="0" bIns="0" rtlCol="0" anchor="ctr">
+            <a:noAutofit/>
+          </a:bodyPr>
+          <a:lstStyle/>
+          <a:p>
+            <a:r>
+              <a:rPr lang="en-US" sz="1400" dirty="0">
+                <a:solidFill>
+                  <a:srgbClr val="394255"/>
+                </a:solidFill>
+                <a:latin typeface="Arial" pitchFamily="34" charset="0"/>
+                <a:ea typeface="Arial" pitchFamily="34" charset="-122"/>
+                <a:cs typeface="Arial" pitchFamily="34" charset="-120"/>
+              </a:rPr>
+              <a:t>Run the seven failure-mode tests with recorded outcomes</a:t>
+            </a:r>
+            <a:endParaRPr lang="en-US" sz="1400" dirty="0"/>
+          </a:p>
+        </p:txBody>
+      </p:sp>
+      <p:sp>
+        <p:nvSpPr>
+          <p:cNvPr id="15" name="Shape 13"/>
+          <p:cNvSpPr/>
+          <p:nvPr/>
+        </p:nvSpPr>
+        <p:spPr>
+          <a:xfrm>
+            <a:off x="2109216" y="3611880"/>
+            <a:ext cx="310896" cy="310896"/>
+          </a:xfrm>
+          <a:prstGeom prst="ellipse">
+            <a:avLst/>
+          </a:prstGeom>
+          <a:solidFill>
+            <a:srgbClr val="182354"/>
+          </a:solidFill>
+          <a:ln w="12700">
+            <a:solidFill>
+              <a:srgbClr val="182354"/>
+            </a:solidFill>
+            <a:prstDash val="solid"/>
+          </a:ln>
+        </p:spPr>
+        <p:txBody>
+          <a:bodyPr/>
+          <a:lstStyle/>
+          <a:p>
+            <a:endParaRPr lang="en-US" sz="1400"/>
+          </a:p>
+        </p:txBody>
+      </p:sp>
+      <p:sp>
+        <p:nvSpPr>
+          <p:cNvPr id="16" name="Text 14"/>
+          <p:cNvSpPr/>
+          <p:nvPr/>
+        </p:nvSpPr>
+        <p:spPr>
+          <a:xfrm>
+            <a:off x="2122932" y="3698748"/>
+            <a:ext cx="283464" cy="73152"/>
+          </a:xfrm>
+          <a:prstGeom prst="rect">
+            <a:avLst/>
+          </a:prstGeom>
+          <a:noFill/>
+          <a:ln/>
+        </p:spPr>
+        <p:txBody>
+          <a:bodyPr wrap="square" lIns="0" tIns="0" rIns="0" bIns="0" rtlCol="0" anchor="ctr"/>
+          <a:lstStyle/>
+          <a:p>
+            <a:pPr algn="ctr"/>
+            <a:r>
+              <a:rPr lang="en-US" sz="1400" b="1" dirty="0">
+                <a:solidFill>
+                  <a:srgbClr val="FFFFFF"/>
+                </a:solidFill>
+                <a:latin typeface="Arial" pitchFamily="34" charset="0"/>
+                <a:ea typeface="Arial" pitchFamily="34" charset="-122"/>
+                <a:cs typeface="Arial" pitchFamily="34" charset="-120"/>
+              </a:rPr>
+              <a:t>04</a:t>
+            </a:r>
+            <a:endParaRPr lang="en-US" sz="1400" dirty="0"/>
+          </a:p>
+        </p:txBody>
+      </p:sp>
+      <p:sp>
+        <p:nvSpPr>
+          <p:cNvPr id="17" name="Text 15"/>
+          <p:cNvSpPr/>
+          <p:nvPr/>
+        </p:nvSpPr>
+        <p:spPr>
+          <a:xfrm>
+            <a:off x="2529840" y="3602736"/>
+            <a:ext cx="3749040" cy="310896"/>
+          </a:xfrm>
+          <a:prstGeom prst="rect">
+            <a:avLst/>
+          </a:prstGeom>
+          <a:noFill/>
+          <a:ln/>
+        </p:spPr>
+        <p:txBody>
+          <a:bodyPr wrap="square" lIns="0" tIns="0" rIns="0" bIns="0" rtlCol="0" anchor="ctr">
+            <a:noAutofit/>
+          </a:bodyPr>
+          <a:lstStyle/>
+          <a:p>
+            <a:r>
+              <a:rPr lang="en-US" sz="1400" dirty="0">
+                <a:solidFill>
+                  <a:srgbClr val="394255"/>
+                </a:solidFill>
+                <a:latin typeface="Arial" pitchFamily="34" charset="0"/>
+                <a:ea typeface="Arial" pitchFamily="34" charset="-122"/>
+                <a:cs typeface="Arial" pitchFamily="34" charset="-120"/>
+              </a:rPr>
+              <a:t>Add HAPI/AU Core validation and terminology mapping checks</a:t>
+            </a:r>
+            <a:endParaRPr lang="en-US" sz="1400" dirty="0"/>
+          </a:p>
+        </p:txBody>
+      </p:sp>
+      <p:sp>
+        <p:nvSpPr>
+          <p:cNvPr id="18" name="Shape 16"/>
+          <p:cNvSpPr/>
+          <p:nvPr/>
+        </p:nvSpPr>
+        <p:spPr>
+          <a:xfrm>
+            <a:off x="2109216" y="4178808"/>
+            <a:ext cx="310896" cy="310896"/>
+          </a:xfrm>
+          <a:prstGeom prst="ellipse">
+            <a:avLst/>
+          </a:prstGeom>
+          <a:solidFill>
+            <a:srgbClr val="182354"/>
+          </a:solidFill>
+          <a:ln w="12700">
+            <a:solidFill>
+              <a:srgbClr val="182354"/>
+            </a:solidFill>
+            <a:prstDash val="solid"/>
+          </a:ln>
+        </p:spPr>
+        <p:txBody>
+          <a:bodyPr/>
+          <a:lstStyle/>
+          <a:p>
+            <a:endParaRPr lang="en-US" sz="1400"/>
+          </a:p>
+        </p:txBody>
+      </p:sp>
+      <p:sp>
+        <p:nvSpPr>
+          <p:cNvPr id="19" name="Text 17"/>
+          <p:cNvSpPr/>
+          <p:nvPr/>
+        </p:nvSpPr>
+        <p:spPr>
+          <a:xfrm>
+            <a:off x="2122932" y="4265676"/>
+            <a:ext cx="283464" cy="73152"/>
+          </a:xfrm>
+          <a:prstGeom prst="rect">
+            <a:avLst/>
+          </a:prstGeom>
+          <a:noFill/>
+          <a:ln/>
+        </p:spPr>
+        <p:txBody>
+          <a:bodyPr wrap="square" lIns="0" tIns="0" rIns="0" bIns="0" rtlCol="0" anchor="ctr"/>
+          <a:lstStyle/>
+          <a:p>
+            <a:pPr algn="ctr"/>
+            <a:r>
+              <a:rPr lang="en-US" sz="1400" b="1" dirty="0">
+                <a:solidFill>
+                  <a:srgbClr val="FFFFFF"/>
+                </a:solidFill>
+                <a:latin typeface="Arial" pitchFamily="34" charset="0"/>
+                <a:ea typeface="Arial" pitchFamily="34" charset="-122"/>
+                <a:cs typeface="Arial" pitchFamily="34" charset="-120"/>
+              </a:rPr>
+              <a:t>05</a:t>
+            </a:r>
+            <a:endParaRPr lang="en-US" sz="1400" dirty="0"/>
+          </a:p>
+        </p:txBody>
+      </p:sp>
+      <p:sp>
+        <p:nvSpPr>
+          <p:cNvPr id="20" name="Text 18"/>
+          <p:cNvSpPr/>
+          <p:nvPr/>
+        </p:nvSpPr>
+        <p:spPr>
+          <a:xfrm>
+            <a:off x="2529840" y="4169664"/>
+            <a:ext cx="3749040" cy="310896"/>
+          </a:xfrm>
+          <a:prstGeom prst="rect">
+            <a:avLst/>
+          </a:prstGeom>
+          <a:noFill/>
+          <a:ln/>
+        </p:spPr>
+        <p:txBody>
+          <a:bodyPr wrap="square" lIns="0" tIns="0" rIns="0" bIns="0" rtlCol="0" anchor="ctr">
+            <a:noAutofit/>
+          </a:bodyPr>
+          <a:lstStyle/>
+          <a:p>
+            <a:r>
+              <a:rPr lang="en-US" sz="1400" dirty="0">
+                <a:solidFill>
+                  <a:srgbClr val="394255"/>
+                </a:solidFill>
+                <a:latin typeface="Arial" pitchFamily="34" charset="0"/>
+                <a:ea typeface="Arial" pitchFamily="34" charset="-122"/>
+                <a:cs typeface="Arial" pitchFamily="34" charset="-120"/>
+              </a:rPr>
+              <a:t>Introduce logging, monitoring and security/privacy review gates</a:t>
+            </a:r>
+            <a:endParaRPr lang="en-US" sz="1400" dirty="0"/>
+          </a:p>
+        </p:txBody>
+      </p:sp>
+      <p:sp>
+        <p:nvSpPr>
+          <p:cNvPr id="21" name="Shape 19"/>
+          <p:cNvSpPr/>
+          <p:nvPr/>
+        </p:nvSpPr>
+        <p:spPr>
+          <a:xfrm>
+            <a:off x="6736080" y="1508760"/>
+            <a:ext cx="3337560" cy="1920240"/>
+          </a:xfrm>
+          <a:prstGeom prst="roundRect">
+            <a:avLst>
+              <a:gd name="adj" fmla="val 2857"/>
+            </a:avLst>
+          </a:prstGeom>
+          <a:solidFill>
+            <a:srgbClr val="F4F6FB"/>
+          </a:solidFill>
+          <a:ln w="12700">
+            <a:solidFill>
+              <a:srgbClr val="DCE3F3"/>
+            </a:solidFill>
+            <a:prstDash val="solid"/>
+          </a:ln>
+        </p:spPr>
+        <p:txBody>
+          <a:bodyPr/>
+          <a:lstStyle/>
+          <a:p>
+            <a:endParaRPr lang="en-US" sz="1400"/>
+          </a:p>
+        </p:txBody>
+      </p:sp>
+      <p:sp>
+        <p:nvSpPr>
+          <p:cNvPr id="22" name="Text 20"/>
+          <p:cNvSpPr/>
+          <p:nvPr/>
+        </p:nvSpPr>
+        <p:spPr>
+          <a:xfrm>
+            <a:off x="6992112" y="1755648"/>
+            <a:ext cx="2834640" cy="201168"/>
+          </a:xfrm>
+          <a:prstGeom prst="rect">
+            <a:avLst/>
+          </a:prstGeom>
+          <a:noFill/>
+          <a:ln/>
+        </p:spPr>
+        <p:txBody>
+          <a:bodyPr wrap="square" lIns="0" tIns="0" rIns="0" bIns="0" rtlCol="0" anchor="ctr"/>
+          <a:lstStyle/>
+          <a:p>
+            <a:pPr algn="ctr"/>
+            <a:r>
+              <a:rPr lang="en-US" sz="1400" b="1" dirty="0">
+                <a:solidFill>
+                  <a:srgbClr val="122033"/>
+                </a:solidFill>
+                <a:latin typeface="Arial" pitchFamily="34" charset="0"/>
+                <a:ea typeface="Arial" pitchFamily="34" charset="-122"/>
+                <a:cs typeface="Arial" pitchFamily="34" charset="-120"/>
+              </a:rPr>
+              <a:t>Current Stage 1 status</a:t>
+            </a:r>
+            <a:endParaRPr lang="en-US" sz="1400" dirty="0"/>
+          </a:p>
+        </p:txBody>
+      </p:sp>
+      <p:sp>
+        <p:nvSpPr>
+          <p:cNvPr id="23" name="Text 21"/>
+          <p:cNvSpPr/>
+          <p:nvPr/>
+        </p:nvSpPr>
+        <p:spPr>
+          <a:xfrm>
+            <a:off x="6992112" y="2148840"/>
+            <a:ext cx="2834640" cy="804672"/>
+          </a:xfrm>
+          <a:prstGeom prst="rect">
+            <a:avLst/>
+          </a:prstGeom>
+          <a:noFill/>
+          <a:ln/>
+        </p:spPr>
+        <p:txBody>
+          <a:bodyPr wrap="square" lIns="254" tIns="254" rIns="254" bIns="254" rtlCol="0" anchor="ctr">
+            <a:noAutofit/>
+          </a:bodyPr>
+          <a:lstStyle/>
+          <a:p>
+            <a:pPr algn="ctr"/>
+            <a:r>
+              <a:rPr lang="en-US" sz="1400" dirty="0">
+                <a:solidFill>
+                  <a:srgbClr val="394255"/>
+                </a:solidFill>
+                <a:latin typeface="Arial" pitchFamily="34" charset="0"/>
+                <a:ea typeface="Arial" pitchFamily="34" charset="-122"/>
+                <a:cs typeface="Arial" pitchFamily="34" charset="-120"/>
+              </a:rPr>
+              <a:t>Limited PoC demonstrated</a:t>
+            </a:r>
+            <a:endParaRPr lang="en-US" sz="1400" dirty="0"/>
+          </a:p>
+          <a:p>
+            <a:pPr algn="ctr"/>
+            <a:r>
+              <a:rPr lang="en-US" sz="1400" dirty="0">
+                <a:solidFill>
+                  <a:srgbClr val="394255"/>
+                </a:solidFill>
+                <a:latin typeface="Arial" pitchFamily="34" charset="0"/>
+                <a:ea typeface="Arial" pitchFamily="34" charset="-122"/>
+                <a:cs typeface="Arial" pitchFamily="34" charset="-120"/>
+              </a:rPr>
+              <a:t>3 Postman tests executed</a:t>
+            </a:r>
+            <a:endParaRPr lang="en-US" sz="1400" dirty="0"/>
+          </a:p>
+          <a:p>
+            <a:pPr algn="ctr"/>
+            <a:r>
+              <a:rPr lang="en-US" sz="1400" dirty="0">
+                <a:solidFill>
+                  <a:srgbClr val="394255"/>
+                </a:solidFill>
+                <a:latin typeface="Arial" pitchFamily="34" charset="0"/>
+                <a:ea typeface="Arial" pitchFamily="34" charset="-122"/>
+                <a:cs typeface="Arial" pitchFamily="34" charset="-120"/>
+              </a:rPr>
+              <a:t>2 Pass / 1 Fail</a:t>
+            </a:r>
+            <a:endParaRPr lang="en-US" sz="1400" dirty="0"/>
+          </a:p>
+          <a:p>
+            <a:pPr algn="ctr"/>
+            <a:r>
+              <a:rPr lang="en-US" sz="1400" dirty="0">
+                <a:solidFill>
+                  <a:srgbClr val="394255"/>
+                </a:solidFill>
+                <a:latin typeface="Arial" pitchFamily="34" charset="0"/>
+                <a:ea typeface="Arial" pitchFamily="34" charset="-122"/>
+                <a:cs typeface="Arial" pitchFamily="34" charset="-120"/>
+              </a:rPr>
+              <a:t>No full deployment readiness</a:t>
+            </a:r>
+            <a:endParaRPr lang="en-US" sz="1400" dirty="0"/>
+          </a:p>
+        </p:txBody>
+      </p:sp>
+      <p:sp>
+        <p:nvSpPr>
+          <p:cNvPr id="24" name="Shape 22"/>
+          <p:cNvSpPr/>
+          <p:nvPr/>
+        </p:nvSpPr>
+        <p:spPr>
+          <a:xfrm>
+            <a:off x="6736080" y="3703320"/>
+            <a:ext cx="3337560" cy="1645920"/>
+          </a:xfrm>
+          <a:prstGeom prst="roundRect">
+            <a:avLst>
+              <a:gd name="adj" fmla="val 3333"/>
+            </a:avLst>
+          </a:prstGeom>
+          <a:solidFill>
+            <a:srgbClr val="182354"/>
+          </a:solidFill>
+          <a:ln w="12700">
+            <a:solidFill>
+              <a:srgbClr val="182354"/>
+            </a:solidFill>
+            <a:prstDash val="solid"/>
+          </a:ln>
+        </p:spPr>
+        <p:txBody>
+          <a:bodyPr/>
+          <a:lstStyle/>
+          <a:p>
+            <a:endParaRPr lang="en-US" sz="1400"/>
+          </a:p>
+        </p:txBody>
+      </p:sp>
+      <p:sp>
+        <p:nvSpPr>
+          <p:cNvPr id="25" name="Text 23"/>
+          <p:cNvSpPr/>
+          <p:nvPr/>
+        </p:nvSpPr>
+        <p:spPr>
+          <a:xfrm>
+            <a:off x="6992112" y="3931920"/>
+            <a:ext cx="2834640" cy="201168"/>
+          </a:xfrm>
+          <a:prstGeom prst="rect">
+            <a:avLst/>
+          </a:prstGeom>
+          <a:noFill/>
+          <a:ln/>
+        </p:spPr>
+        <p:txBody>
+          <a:bodyPr wrap="square" lIns="0" tIns="0" rIns="0" bIns="0" rtlCol="0" anchor="ctr"/>
+          <a:lstStyle/>
+          <a:p>
+            <a:pPr algn="ctr"/>
+            <a:r>
+              <a:rPr lang="en-US" sz="1400" b="1" dirty="0">
+                <a:solidFill>
+                  <a:srgbClr val="FFFFFF"/>
+                </a:solidFill>
+                <a:latin typeface="Arial" pitchFamily="34" charset="0"/>
+                <a:ea typeface="Arial" pitchFamily="34" charset="-122"/>
+                <a:cs typeface="Arial" pitchFamily="34" charset="-120"/>
+              </a:rPr>
+              <a:t>Recommendation</a:t>
+            </a:r>
+            <a:endParaRPr lang="en-US" sz="1400" dirty="0"/>
+          </a:p>
+        </p:txBody>
+      </p:sp>
+      <p:sp>
+        <p:nvSpPr>
+          <p:cNvPr id="26" name="Text 24"/>
+          <p:cNvSpPr/>
+          <p:nvPr/>
+        </p:nvSpPr>
+        <p:spPr>
+          <a:xfrm>
+            <a:off x="7028688" y="4343400"/>
+            <a:ext cx="2743200" cy="530352"/>
+          </a:xfrm>
+          <a:prstGeom prst="rect">
+            <a:avLst/>
+          </a:prstGeom>
+          <a:noFill/>
+          <a:ln/>
+        </p:spPr>
+        <p:txBody>
+          <a:bodyPr wrap="square" lIns="254" tIns="254" rIns="254" bIns="254" rtlCol="0" anchor="ctr">
+            <a:noAutofit/>
+          </a:bodyPr>
+          <a:lstStyle/>
+          <a:p>
+            <a:pPr algn="ctr"/>
+            <a:r>
+              <a:rPr lang="en-US" sz="1400" dirty="0">
+                <a:solidFill>
+                  <a:srgbClr val="EEF2FF"/>
+                </a:solidFill>
+                <a:latin typeface="Arial" pitchFamily="34" charset="0"/>
+                <a:ea typeface="Arial" pitchFamily="34" charset="-122"/>
+                <a:cs typeface="Arial" pitchFamily="34" charset="-120"/>
+              </a:rPr>
+              <a:t>Proceed to ICT946 implementation ,but present the current work as a design-stage PoC — not as a production-ready harness.</a:t>
+            </a:r>
+            <a:endParaRPr lang="en-US" sz="1400" dirty="0"/>
+          </a:p>
+        </p:txBody>
+      </p:sp>
+      <p:sp>
+        <p:nvSpPr>
+          <p:cNvPr id="27" name="Shape 25"/>
+          <p:cNvSpPr/>
+          <p:nvPr/>
+        </p:nvSpPr>
+        <p:spPr>
+          <a:xfrm>
+            <a:off x="2054352" y="5641848"/>
+            <a:ext cx="8092440" cy="384048"/>
+          </a:xfrm>
+          <a:prstGeom prst="roundRect">
+            <a:avLst>
+              <a:gd name="adj" fmla="val 11905"/>
+            </a:avLst>
+          </a:prstGeom>
+          <a:solidFill>
+            <a:srgbClr val="F4F6FB"/>
+          </a:solidFill>
+          <a:ln w="12700">
+            <a:solidFill>
+              <a:srgbClr val="DCE3F3"/>
+            </a:solidFill>
+            <a:prstDash val="solid"/>
+          </a:ln>
+        </p:spPr>
+        <p:txBody>
+          <a:bodyPr/>
+          <a:lstStyle/>
+          <a:p>
+            <a:endParaRPr lang="en-US" sz="1400"/>
+          </a:p>
+        </p:txBody>
+      </p:sp>
+      <p:sp>
+        <p:nvSpPr>
+          <p:cNvPr id="28" name="Text 26"/>
+          <p:cNvSpPr/>
+          <p:nvPr/>
+        </p:nvSpPr>
+        <p:spPr>
+          <a:xfrm>
+            <a:off x="2273808" y="5769864"/>
+            <a:ext cx="7635240" cy="91440"/>
+          </a:xfrm>
+          <a:prstGeom prst="rect">
+            <a:avLst/>
+          </a:prstGeom>
+          <a:noFill/>
+          <a:ln/>
+        </p:spPr>
+        <p:txBody>
+          <a:bodyPr wrap="square" lIns="0" tIns="0" rIns="0" bIns="0" rtlCol="0" anchor="ctr"/>
+          <a:lstStyle/>
+          <a:p>
+            <a:pPr algn="ctr"/>
+            <a:r>
+              <a:rPr lang="en-US" sz="1400" b="1" dirty="0">
+                <a:solidFill>
+                  <a:srgbClr val="122033"/>
+                </a:solidFill>
+                <a:latin typeface="Arial" pitchFamily="34" charset="0"/>
+                <a:ea typeface="Arial" pitchFamily="34" charset="-122"/>
+                <a:cs typeface="Arial" pitchFamily="34" charset="-120"/>
+              </a:rPr>
+              <a:t>Message for the audience: the PoC proves feasibility and exposes gaps; Stage 2 proves reliability, security and repeatability.</a:t>
+            </a:r>
+            <a:endParaRPr lang="en-US" sz="1400" dirty="0"/>
+          </a:p>
+        </p:txBody>
+      </p:sp>
+      <p:sp>
+        <p:nvSpPr>
+          <p:cNvPr id="29" name="Text 27"/>
+          <p:cNvSpPr/>
+          <p:nvPr/>
+        </p:nvSpPr>
+        <p:spPr>
+          <a:xfrm>
+            <a:off x="9936480" y="6510528"/>
+            <a:ext cx="457200" cy="164592"/>
+          </a:xfrm>
+          <a:prstGeom prst="rect">
+            <a:avLst/>
+          </a:prstGeom>
+          <a:noFill/>
+          <a:ln/>
+        </p:spPr>
+        <p:txBody>
+          <a:bodyPr wrap="square" lIns="0" tIns="0" rIns="0" bIns="0" rtlCol="0" anchor="ctr"/>
+          <a:lstStyle/>
+          <a:p>
+            <a:pPr algn="r"/>
+            <a:r>
+              <a:rPr lang="en-US" sz="700" dirty="0">
+                <a:solidFill>
+                  <a:srgbClr val="7D8798"/>
+                </a:solidFill>
+                <a:latin typeface="Arial" pitchFamily="34" charset="0"/>
+                <a:ea typeface="Arial" pitchFamily="34" charset="-122"/>
+                <a:cs typeface="Arial" pitchFamily="34" charset="-120"/>
+              </a:rPr>
+              <a:t>25</a:t>
+            </a:r>
+            <a:endParaRPr lang="en-US" sz="700" dirty="0"/>
+          </a:p>
+        </p:txBody>
+      </p:sp>
+    </p:spTree>
+  </p:cSld>
+  <p:clrMapOvr>
+    <a:masterClrMapping/>
+  </p:clrMapOvr>
+</p:sld>
+</file>
+
+<file path=ppt/slides/slide24.xml><?xml version="1.0" encoding="utf-8"?>
 <p:sld xmlns:a="http://schemas.openxmlformats.org/drawingml/2006/main" xmlns:r="http://schemas.openxmlformats.org/officeDocument/2006/relationships" xmlns:p="http://schemas.openxmlformats.org/presentationml/2006/main">
   <p:cSld>
     <p:bg>
@@ -23224,7 +25406,7 @@
 </p:sld>
 </file>
 
-<file path=ppt/slides/slide23.xml><?xml version="1.0" encoding="utf-8"?>
+<file path=ppt/slides/slide25.xml><?xml version="1.0" encoding="utf-8"?>
 <p:sld xmlns:a="http://schemas.openxmlformats.org/drawingml/2006/main" xmlns:r="http://schemas.openxmlformats.org/officeDocument/2006/relationships" xmlns:p="http://schemas.openxmlformats.org/presentationml/2006/main">
   <p:cSld>
     <p:spTree>
@@ -23563,7 +25745,7 @@
 </p:sld>
 </file>
 
-<file path=ppt/slides/slide24.xml><?xml version="1.0" encoding="utf-8"?>
+<file path=ppt/slides/slide26.xml><?xml version="1.0" encoding="utf-8"?>
 <p:sld xmlns:a="http://schemas.openxmlformats.org/drawingml/2006/main" xmlns:r="http://schemas.openxmlformats.org/officeDocument/2006/relationships" xmlns:p="http://schemas.openxmlformats.org/presentationml/2006/main">
   <p:cSld>
     <p:spTree>

</xml_diff>